<commit_message>
Add folder structure slide to office hub concept deck
New slide 11 shows the Drive folder structure that drives each tab's
auto-updating embed, plus the Learning Sessions archive grouped by month
(YYYY-MM-DD_Title naming). Meant to be pulled into the already-converted
Google Slides copy via File > Import slides, not a replacement for it.

Co-Authored-By: Claude Sonnet 5 <noreply@anthropic.com>
Claude-Session: https://claude.ai/code/session_01YAQcUYpy57Up3cir28mVUA
</commit_message>
<xml_diff>
--- a/office-hub-concept.pptx
+++ b/office-hub-concept.pptx
@@ -15,9 +15,10 @@
     <p:sldId id="263" r:id="rId9"/>
     <p:sldId id="264" r:id="rId10"/>
     <p:sldId id="265" r:id="rId11"/>
+    <p:sldId id="266" r:id="rId12"/>
   </p:sldIdLst>
   <p:notesMasterIdLst>
-    <p:notesMasterId r:id="rId12"/>
+    <p:notesMasterId r:id="rId13"/>
   </p:notesMasterIdLst>
   <p:sldSz cx="12192000" cy="6858000"/>
   <p:notesSz cx="6858000" cy="12192000"/>
@@ -623,6 +624,94 @@
             <a:fld id="{F7021451-1387-4CA6-816F-3879F97B5CBC}" type="slidenum">
               <a:rPr lang="en-US"/>
               <a:t>10</a:t>
+            </a:fld>
+            <a:endParaRPr lang="en-US"/>
+          </a:p>
+        </p:txBody>
+      </p:sp>
+    </p:spTree>
+    <p:extLst>
+      <p:ext uri="{BB962C8B-B14F-4D97-AF65-F5344CB8AC3E}">
+        <p14:creationId xmlns:p14="http://schemas.microsoft.com/office/powerpoint/2010/main" val="1024086991"/>
+      </p:ext>
+    </p:extLst>
+  </p:cSld>
+  <p:clrMapOvr>
+    <a:masterClrMapping/>
+  </p:clrMapOvr>
+</p:notes>
+</file>
+
+<file path=ppt/notesSlides/notesSlide11.xml><?xml version="1.0" encoding="utf-8"?>
+<p:notes xmlns:a="http://schemas.openxmlformats.org/drawingml/2006/main" xmlns:r="http://schemas.openxmlformats.org/officeDocument/2006/relationships" xmlns:p="http://schemas.openxmlformats.org/presentationml/2006/main">
+  <p:cSld>
+    <p:spTree>
+      <p:nvGrpSpPr>
+        <p:cNvPr id="1" name=""/>
+        <p:cNvGrpSpPr/>
+        <p:nvPr/>
+      </p:nvGrpSpPr>
+      <p:grpSpPr>
+        <a:xfrm>
+          <a:off x="0" y="0"/>
+          <a:ext cx="0" cy="0"/>
+          <a:chOff x="0" y="0"/>
+          <a:chExt cx="0" cy="0"/>
+        </a:xfrm>
+      </p:grpSpPr>
+      <p:sp>
+        <p:nvSpPr>
+          <p:cNvPr id="2" name="Slide Image Placeholder 1"/>
+          <p:cNvSpPr>
+            <a:spLocks noGrp="1" noRot="1" noChangeAspect="1"/>
+          </p:cNvSpPr>
+          <p:nvPr>
+            <p:ph type="sldImg"/>
+          </p:nvPr>
+        </p:nvSpPr>
+        <p:spPr/>
+      </p:sp>
+      <p:sp>
+        <p:nvSpPr>
+          <p:cNvPr id="3" name="Notes Placeholder 2"/>
+          <p:cNvSpPr>
+            <a:spLocks noGrp="1"/>
+          </p:cNvSpPr>
+          <p:nvPr>
+            <p:ph type="body" idx="1"/>
+          </p:nvPr>
+        </p:nvSpPr>
+        <p:spPr/>
+        <p:txBody>
+          <a:bodyPr/>
+          <a:lstStyle/>
+          <a:p>
+            <a:r>
+              <a:rPr lang="en-US" dirty="0"/>
+              <a:t/>
+            </a:r>
+            <a:endParaRPr lang="en-US" dirty="0"/>
+          </a:p>
+        </p:txBody>
+      </p:sp>
+      <p:sp>
+        <p:nvSpPr>
+          <p:cNvPr id="4" name="Slide Number Placeholder 3"/>
+          <p:cNvSpPr>
+            <a:spLocks noGrp="1"/>
+          </p:cNvSpPr>
+          <p:nvPr>
+            <p:ph type="sldNum" sz="quarter" idx="10"/>
+          </p:nvPr>
+        </p:nvSpPr>
+        <p:spPr/>
+        <p:txBody>
+          <a:bodyPr/>
+          <a:lstStyle/>
+          <a:p>
+            <a:fld id="{F7021451-1387-4CA6-816F-3879F97B5CBC}" type="slidenum">
+              <a:rPr lang="en-US"/>
+              <a:t>11</a:t>
             </a:fld>
             <a:endParaRPr lang="en-US"/>
           </a:p>
@@ -4173,6 +4262,1110 @@
 </p:sld>
 </file>
 
+<file path=ppt/slides/slide11.xml><?xml version="1.0" encoding="utf-8"?>
+<p:sld xmlns:a="http://schemas.openxmlformats.org/drawingml/2006/main" xmlns:r="http://schemas.openxmlformats.org/officeDocument/2006/relationships" xmlns:p="http://schemas.openxmlformats.org/presentationml/2006/main">
+  <p:cSld name="Slide 11">
+    <p:bg>
+      <p:bgPr>
+        <a:solidFill>
+          <a:srgbClr val="12233A"/>
+        </a:solidFill>
+      </p:bgPr>
+    </p:bg>
+    <p:spTree>
+      <p:nvGrpSpPr>
+        <p:cNvPr id="1" name=""/>
+        <p:cNvGrpSpPr/>
+        <p:nvPr/>
+      </p:nvGrpSpPr>
+      <p:grpSpPr>
+        <a:xfrm>
+          <a:off x="0" y="0"/>
+          <a:ext cx="0" cy="0"/>
+          <a:chOff x="0" y="0"/>
+          <a:chExt cx="0" cy="0"/>
+        </a:xfrm>
+      </p:grpSpPr>
+      <p:sp>
+        <p:nvSpPr>
+          <p:cNvPr id="2" name="Text 0"/>
+          <p:cNvSpPr txBox="1"/>
+          <p:nvPr/>
+        </p:nvSpPr>
+        <p:spPr>
+          <a:xfrm>
+            <a:off x="822960" y="502920"/>
+            <a:ext cx="7315200" cy="274320"/>
+          </a:xfrm>
+          <a:prstGeom prst="rect">
+            <a:avLst/>
+          </a:prstGeom>
+          <a:noFill/>
+          <a:ln/>
+        </p:spPr>
+        <p:txBody>
+          <a:bodyPr wrap="square" lIns="0" tIns="0" rIns="0" bIns="0" rtlCol="0" anchor="ctr"/>
+          <a:lstStyle/>
+          <a:p>
+            <a:pPr indent="0" marL="0">
+              <a:buNone/>
+            </a:pPr>
+            <a:r>
+              <a:rPr lang="en-US" sz="1100" spc="200" kern="0" dirty="0">
+                <a:solidFill>
+                  <a:srgbClr val="7FA0BE"/>
+                </a:solidFill>
+                <a:latin typeface="Courier New" pitchFamily="34" charset="0"/>
+                <a:ea typeface="Courier New" pitchFamily="34" charset="-122"/>
+                <a:cs typeface="Courier New" pitchFamily="34" charset="-120"/>
+              </a:rPr>
+              <a:t>SAMPLE</a:t>
+            </a:r>
+            <a:endParaRPr lang="en-US" sz="1100" dirty="0"/>
+          </a:p>
+        </p:txBody>
+      </p:sp>
+      <p:sp>
+        <p:nvSpPr>
+          <p:cNvPr id="3" name="Text 1"/>
+          <p:cNvSpPr txBox="1"/>
+          <p:nvPr/>
+        </p:nvSpPr>
+        <p:spPr>
+          <a:xfrm>
+            <a:off x="777240" y="777240"/>
+            <a:ext cx="10515600" cy="640080"/>
+          </a:xfrm>
+          <a:prstGeom prst="rect">
+            <a:avLst/>
+          </a:prstGeom>
+          <a:noFill/>
+          <a:ln/>
+        </p:spPr>
+        <p:txBody>
+          <a:bodyPr wrap="square" lIns="0" tIns="0" rIns="0" bIns="0" rtlCol="0" anchor="ctr"/>
+          <a:lstStyle/>
+          <a:p>
+            <a:pPr indent="0" marL="0">
+              <a:buNone/>
+            </a:pPr>
+            <a:r>
+              <a:rPr lang="en-US" sz="3000" b="1" dirty="0">
+                <a:solidFill>
+                  <a:srgbClr val="F4F6F7"/>
+                </a:solidFill>
+                <a:latin typeface="Arial" pitchFamily="34" charset="0"/>
+                <a:ea typeface="Arial" pitchFamily="34" charset="-122"/>
+                <a:cs typeface="Arial" pitchFamily="34" charset="-120"/>
+              </a:rPr>
+              <a:t>Office Hub — Folder Structure</a:t>
+            </a:r>
+            <a:endParaRPr lang="en-US" sz="3000" dirty="0"/>
+          </a:p>
+        </p:txBody>
+      </p:sp>
+      <p:sp>
+        <p:nvSpPr>
+          <p:cNvPr id="4" name="Text 2"/>
+          <p:cNvSpPr txBox="1"/>
+          <p:nvPr/>
+        </p:nvSpPr>
+        <p:spPr>
+          <a:xfrm>
+            <a:off x="822960" y="1298448"/>
+            <a:ext cx="10058400" cy="365760"/>
+          </a:xfrm>
+          <a:prstGeom prst="rect">
+            <a:avLst/>
+          </a:prstGeom>
+          <a:noFill/>
+          <a:ln/>
+        </p:spPr>
+        <p:txBody>
+          <a:bodyPr wrap="square" lIns="0" tIns="0" rIns="0" bIns="0" rtlCol="0" anchor="ctr"/>
+          <a:lstStyle/>
+          <a:p>
+            <a:pPr indent="0" marL="0">
+              <a:buNone/>
+            </a:pPr>
+            <a:r>
+              <a:rPr lang="en-US" sz="1200" dirty="0">
+                <a:solidFill>
+                  <a:srgbClr val="C7D6E2"/>
+                </a:solidFill>
+                <a:latin typeface="Calibri" pitchFamily="34" charset="0"/>
+                <a:ea typeface="Calibri" pitchFamily="34" charset="-122"/>
+                <a:cs typeface="Calibri" pitchFamily="34" charset="-120"/>
+              </a:rPr>
+              <a:t>Drive folders that drive every auto-updating page — upload a file here, it shows up on the site. No page edit needed.</a:t>
+            </a:r>
+            <a:endParaRPr lang="en-US" sz="1200" dirty="0"/>
+          </a:p>
+        </p:txBody>
+      </p:sp>
+      <p:sp>
+        <p:nvSpPr>
+          <p:cNvPr id="5" name="Shape 3"/>
+          <p:cNvSpPr/>
+          <p:nvPr/>
+        </p:nvSpPr>
+        <p:spPr>
+          <a:xfrm>
+            <a:off x="777240" y="1874520"/>
+            <a:ext cx="5943600" cy="4617720"/>
+          </a:xfrm>
+          <a:prstGeom prst="roundRect">
+            <a:avLst>
+              <a:gd name="adj" fmla="val 1188"/>
+            </a:avLst>
+          </a:prstGeom>
+          <a:solidFill>
+            <a:srgbClr val="0F2A46"/>
+          </a:solidFill>
+          <a:ln w="12700">
+            <a:solidFill>
+              <a:srgbClr val="2C5478"/>
+            </a:solidFill>
+            <a:prstDash val="solid"/>
+          </a:ln>
+        </p:spPr>
+      </p:sp>
+      <p:sp>
+        <p:nvSpPr>
+          <p:cNvPr id="6" name="Text 4"/>
+          <p:cNvSpPr txBox="1"/>
+          <p:nvPr/>
+        </p:nvSpPr>
+        <p:spPr>
+          <a:xfrm>
+            <a:off x="1005840" y="2029968"/>
+            <a:ext cx="4572000" cy="219456"/>
+          </a:xfrm>
+          <a:prstGeom prst="rect">
+            <a:avLst/>
+          </a:prstGeom>
+          <a:noFill/>
+          <a:ln/>
+        </p:spPr>
+        <p:txBody>
+          <a:bodyPr wrap="square" lIns="0" tIns="0" rIns="0" bIns="0" rtlCol="0" anchor="ctr"/>
+          <a:lstStyle/>
+          <a:p>
+            <a:pPr indent="0" marL="0">
+              <a:buNone/>
+            </a:pPr>
+            <a:r>
+              <a:rPr lang="en-US" sz="900" spc="100" kern="0" dirty="0">
+                <a:solidFill>
+                  <a:srgbClr val="7FA0BE"/>
+                </a:solidFill>
+                <a:latin typeface="Courier New" pitchFamily="34" charset="0"/>
+                <a:ea typeface="Courier New" pitchFamily="34" charset="-122"/>
+                <a:cs typeface="Courier New" pitchFamily="34" charset="-120"/>
+              </a:rPr>
+              <a:t>EVERY TAB</a:t>
+            </a:r>
+            <a:endParaRPr lang="en-US" sz="900" dirty="0"/>
+          </a:p>
+        </p:txBody>
+      </p:sp>
+      <p:sp>
+        <p:nvSpPr>
+          <p:cNvPr id="7" name="Text 5"/>
+          <p:cNvSpPr txBox="1"/>
+          <p:nvPr/>
+        </p:nvSpPr>
+        <p:spPr>
+          <a:xfrm>
+            <a:off x="1005840" y="2304288"/>
+            <a:ext cx="5486400" cy="4023360"/>
+          </a:xfrm>
+          <a:prstGeom prst="rect">
+            <a:avLst/>
+          </a:prstGeom>
+          <a:noFill/>
+          <a:ln/>
+        </p:spPr>
+        <p:txBody>
+          <a:bodyPr wrap="square" lIns="0" tIns="0" rIns="0" bIns="0" rtlCol="0" anchor="t"/>
+          <a:lstStyle/>
+          <a:p>
+            <a:pPr indent="0" marL="0">
+              <a:lnSpc>
+                <a:spcPct val="112000"/>
+              </a:lnSpc>
+              <a:buNone/>
+            </a:pPr>
+            <a:r>
+              <a:rPr lang="en-US" sz="1100" dirty="0">
+                <a:solidFill>
+                  <a:srgbClr val="E9F1F6"/>
+                </a:solidFill>
+                <a:latin typeface="Courier New" pitchFamily="34" charset="0"/>
+                <a:ea typeface="Courier New" pitchFamily="34" charset="-122"/>
+                <a:cs typeface="Courier New" pitchFamily="34" charset="-120"/>
+              </a:rPr>
+              <a:t>Office Hub/</a:t>
+            </a:r>
+            <a:endParaRPr lang="en-US" sz="1100" dirty="0"/>
+          </a:p>
+          <a:p>
+            <a:pPr indent="0" marL="0">
+              <a:lnSpc>
+                <a:spcPct val="112000"/>
+              </a:lnSpc>
+              <a:buNone/>
+            </a:pPr>
+            <a:r>
+              <a:rPr lang="en-US" sz="1100" dirty="0">
+                <a:solidFill>
+                  <a:srgbClr val="E9F1F6"/>
+                </a:solidFill>
+                <a:latin typeface="Courier New" pitchFamily="34" charset="0"/>
+                <a:ea typeface="Courier New" pitchFamily="34" charset="-122"/>
+                <a:cs typeface="Courier New" pitchFamily="34" charset="-120"/>
+              </a:rPr>
+              <a:t>├── 01 Office Standards/</a:t>
+            </a:r>
+            <a:endParaRPr lang="en-US" sz="1100" dirty="0"/>
+          </a:p>
+          <a:p>
+            <a:pPr indent="0" marL="0">
+              <a:lnSpc>
+                <a:spcPct val="112000"/>
+              </a:lnSpc>
+              <a:buNone/>
+            </a:pPr>
+            <a:r>
+              <a:rPr lang="en-US" sz="1100" dirty="0">
+                <a:solidFill>
+                  <a:srgbClr val="E9F1F6"/>
+                </a:solidFill>
+                <a:latin typeface="Courier New" pitchFamily="34" charset="0"/>
+                <a:ea typeface="Courier New" pitchFamily="34" charset="-122"/>
+                <a:cs typeface="Courier New" pitchFamily="34" charset="-120"/>
+              </a:rPr>
+              <a:t>│   ├── Office Standards Manual/</a:t>
+            </a:r>
+            <a:endParaRPr lang="en-US" sz="1100" dirty="0"/>
+          </a:p>
+          <a:p>
+            <a:pPr indent="0" marL="0">
+              <a:lnSpc>
+                <a:spcPct val="112000"/>
+              </a:lnSpc>
+              <a:buNone/>
+            </a:pPr>
+            <a:r>
+              <a:rPr lang="en-US" sz="1100" dirty="0">
+                <a:solidFill>
+                  <a:srgbClr val="E9F1F6"/>
+                </a:solidFill>
+                <a:latin typeface="Courier New" pitchFamily="34" charset="0"/>
+                <a:ea typeface="Courier New" pitchFamily="34" charset="-122"/>
+                <a:cs typeface="Courier New" pitchFamily="34" charset="-120"/>
+              </a:rPr>
+              <a:t>│   ├── Drafting Standards/</a:t>
+            </a:r>
+            <a:endParaRPr lang="en-US" sz="1100" dirty="0"/>
+          </a:p>
+          <a:p>
+            <a:pPr indent="0" marL="0">
+              <a:lnSpc>
+                <a:spcPct val="112000"/>
+              </a:lnSpc>
+              <a:buNone/>
+            </a:pPr>
+            <a:r>
+              <a:rPr lang="en-US" sz="1100" dirty="0">
+                <a:solidFill>
+                  <a:srgbClr val="E9F1F6"/>
+                </a:solidFill>
+                <a:latin typeface="Courier New" pitchFamily="34" charset="0"/>
+                <a:ea typeface="Courier New" pitchFamily="34" charset="-122"/>
+                <a:cs typeface="Courier New" pitchFamily="34" charset="-120"/>
+              </a:rPr>
+              <a:t>│   └── File Naming &amp; Project Setup/</a:t>
+            </a:r>
+            <a:endParaRPr lang="en-US" sz="1100" dirty="0"/>
+          </a:p>
+          <a:p>
+            <a:pPr indent="0" marL="0">
+              <a:lnSpc>
+                <a:spcPct val="112000"/>
+              </a:lnSpc>
+              <a:buNone/>
+            </a:pPr>
+            <a:r>
+              <a:rPr lang="en-US" sz="1100" dirty="0">
+                <a:solidFill>
+                  <a:srgbClr val="E9F1F6"/>
+                </a:solidFill>
+                <a:latin typeface="Courier New" pitchFamily="34" charset="0"/>
+                <a:ea typeface="Courier New" pitchFamily="34" charset="-122"/>
+                <a:cs typeface="Courier New" pitchFamily="34" charset="-120"/>
+              </a:rPr>
+              <a:t>├── 02 Templates/</a:t>
+            </a:r>
+            <a:endParaRPr lang="en-US" sz="1100" dirty="0"/>
+          </a:p>
+          <a:p>
+            <a:pPr indent="0" marL="0">
+              <a:lnSpc>
+                <a:spcPct val="112000"/>
+              </a:lnSpc>
+              <a:buNone/>
+            </a:pPr>
+            <a:r>
+              <a:rPr lang="en-US" sz="1100" dirty="0">
+                <a:solidFill>
+                  <a:srgbClr val="E9F1F6"/>
+                </a:solidFill>
+                <a:latin typeface="Courier New" pitchFamily="34" charset="0"/>
+                <a:ea typeface="Courier New" pitchFamily="34" charset="-122"/>
+                <a:cs typeface="Courier New" pitchFamily="34" charset="-120"/>
+              </a:rPr>
+              <a:t>│   └── Drawing Title Blocks/</a:t>
+            </a:r>
+            <a:endParaRPr lang="en-US" sz="1100" dirty="0"/>
+          </a:p>
+          <a:p>
+            <a:pPr indent="0" marL="0">
+              <a:lnSpc>
+                <a:spcPct val="112000"/>
+              </a:lnSpc>
+              <a:buNone/>
+            </a:pPr>
+            <a:r>
+              <a:rPr lang="en-US" sz="1100" dirty="0">
+                <a:solidFill>
+                  <a:srgbClr val="E9F1F6"/>
+                </a:solidFill>
+                <a:latin typeface="Courier New" pitchFamily="34" charset="0"/>
+                <a:ea typeface="Courier New" pitchFamily="34" charset="-122"/>
+                <a:cs typeface="Courier New" pitchFamily="34" charset="-120"/>
+              </a:rPr>
+              <a:t>├── 03 Forms/</a:t>
+            </a:r>
+            <a:endParaRPr lang="en-US" sz="1100" dirty="0"/>
+          </a:p>
+          <a:p>
+            <a:pPr indent="0" marL="0">
+              <a:lnSpc>
+                <a:spcPct val="112000"/>
+              </a:lnSpc>
+              <a:buNone/>
+            </a:pPr>
+            <a:r>
+              <a:rPr lang="en-US" sz="1100" dirty="0">
+                <a:solidFill>
+                  <a:srgbClr val="E9F1F6"/>
+                </a:solidFill>
+                <a:latin typeface="Courier New" pitchFamily="34" charset="0"/>
+                <a:ea typeface="Courier New" pitchFamily="34" charset="-122"/>
+                <a:cs typeface="Courier New" pitchFamily="34" charset="-120"/>
+              </a:rPr>
+              <a:t>│   ├── HR Forms/</a:t>
+            </a:r>
+            <a:endParaRPr lang="en-US" sz="1100" dirty="0"/>
+          </a:p>
+          <a:p>
+            <a:pPr indent="0" marL="0">
+              <a:lnSpc>
+                <a:spcPct val="112000"/>
+              </a:lnSpc>
+              <a:buNone/>
+            </a:pPr>
+            <a:r>
+              <a:rPr lang="en-US" sz="1100" dirty="0">
+                <a:solidFill>
+                  <a:srgbClr val="E9F1F6"/>
+                </a:solidFill>
+                <a:latin typeface="Courier New" pitchFamily="34" charset="0"/>
+                <a:ea typeface="Courier New" pitchFamily="34" charset="-122"/>
+                <a:cs typeface="Courier New" pitchFamily="34" charset="-120"/>
+              </a:rPr>
+              <a:t>│   ├── Finance Forms/</a:t>
+            </a:r>
+            <a:endParaRPr lang="en-US" sz="1100" dirty="0"/>
+          </a:p>
+          <a:p>
+            <a:pPr indent="0" marL="0">
+              <a:lnSpc>
+                <a:spcPct val="112000"/>
+              </a:lnSpc>
+              <a:buNone/>
+            </a:pPr>
+            <a:r>
+              <a:rPr lang="en-US" sz="1100" dirty="0">
+                <a:solidFill>
+                  <a:srgbClr val="E9F1F6"/>
+                </a:solidFill>
+                <a:latin typeface="Courier New" pitchFamily="34" charset="0"/>
+                <a:ea typeface="Courier New" pitchFamily="34" charset="-122"/>
+                <a:cs typeface="Courier New" pitchFamily="34" charset="-120"/>
+              </a:rPr>
+              <a:t>│   └── Project Admin Forms/</a:t>
+            </a:r>
+            <a:endParaRPr lang="en-US" sz="1100" dirty="0"/>
+          </a:p>
+          <a:p>
+            <a:pPr indent="0" marL="0">
+              <a:lnSpc>
+                <a:spcPct val="112000"/>
+              </a:lnSpc>
+              <a:buNone/>
+            </a:pPr>
+            <a:r>
+              <a:rPr lang="en-US" sz="1100" dirty="0">
+                <a:solidFill>
+                  <a:srgbClr val="E9F1F6"/>
+                </a:solidFill>
+                <a:latin typeface="Courier New" pitchFamily="34" charset="0"/>
+                <a:ea typeface="Courier New" pitchFamily="34" charset="-122"/>
+                <a:cs typeface="Courier New" pitchFamily="34" charset="-120"/>
+              </a:rPr>
+              <a:t>├── 04 Office Policies/</a:t>
+            </a:r>
+            <a:endParaRPr lang="en-US" sz="1100" dirty="0"/>
+          </a:p>
+          <a:p>
+            <a:pPr indent="0" marL="0">
+              <a:lnSpc>
+                <a:spcPct val="112000"/>
+              </a:lnSpc>
+              <a:buNone/>
+            </a:pPr>
+            <a:r>
+              <a:rPr lang="en-US" sz="1100" dirty="0">
+                <a:solidFill>
+                  <a:srgbClr val="E9F1F6"/>
+                </a:solidFill>
+                <a:latin typeface="Courier New" pitchFamily="34" charset="0"/>
+                <a:ea typeface="Courier New" pitchFamily="34" charset="-122"/>
+                <a:cs typeface="Courier New" pitchFamily="34" charset="-120"/>
+              </a:rPr>
+              <a:t>│   ├── Employee Handbook/</a:t>
+            </a:r>
+            <a:endParaRPr lang="en-US" sz="1100" dirty="0"/>
+          </a:p>
+          <a:p>
+            <a:pPr indent="0" marL="0">
+              <a:lnSpc>
+                <a:spcPct val="112000"/>
+              </a:lnSpc>
+              <a:buNone/>
+            </a:pPr>
+            <a:r>
+              <a:rPr lang="en-US" sz="1100" dirty="0">
+                <a:solidFill>
+                  <a:srgbClr val="E9F1F6"/>
+                </a:solidFill>
+                <a:latin typeface="Courier New" pitchFamily="34" charset="0"/>
+                <a:ea typeface="Courier New" pitchFamily="34" charset="-122"/>
+                <a:cs typeface="Courier New" pitchFamily="34" charset="-120"/>
+              </a:rPr>
+              <a:t>│   ├── Health &amp; Safety/</a:t>
+            </a:r>
+            <a:endParaRPr lang="en-US" sz="1100" dirty="0"/>
+          </a:p>
+          <a:p>
+            <a:pPr indent="0" marL="0">
+              <a:lnSpc>
+                <a:spcPct val="112000"/>
+              </a:lnSpc>
+              <a:buNone/>
+            </a:pPr>
+            <a:r>
+              <a:rPr lang="en-US" sz="1100" dirty="0">
+                <a:solidFill>
+                  <a:srgbClr val="E9F1F6"/>
+                </a:solidFill>
+                <a:latin typeface="Courier New" pitchFamily="34" charset="0"/>
+                <a:ea typeface="Courier New" pitchFamily="34" charset="-122"/>
+                <a:cs typeface="Courier New" pitchFamily="34" charset="-120"/>
+              </a:rPr>
+              <a:t>│   ├── Remote Work &amp; IT Use/</a:t>
+            </a:r>
+            <a:endParaRPr lang="en-US" sz="1100" dirty="0"/>
+          </a:p>
+          <a:p>
+            <a:pPr indent="0" marL="0">
+              <a:lnSpc>
+                <a:spcPct val="112000"/>
+              </a:lnSpc>
+              <a:buNone/>
+            </a:pPr>
+            <a:r>
+              <a:rPr lang="en-US" sz="1100" dirty="0">
+                <a:solidFill>
+                  <a:srgbClr val="E9F1F6"/>
+                </a:solidFill>
+                <a:latin typeface="Courier New" pitchFamily="34" charset="0"/>
+                <a:ea typeface="Courier New" pitchFamily="34" charset="-122"/>
+                <a:cs typeface="Courier New" pitchFamily="34" charset="-120"/>
+              </a:rPr>
+              <a:t>│   └── Benefits &amp; HR Policies/</a:t>
+            </a:r>
+            <a:endParaRPr lang="en-US" sz="1100" dirty="0"/>
+          </a:p>
+          <a:p>
+            <a:pPr indent="0" marL="0">
+              <a:lnSpc>
+                <a:spcPct val="112000"/>
+              </a:lnSpc>
+              <a:buNone/>
+            </a:pPr>
+            <a:r>
+              <a:rPr lang="en-US" sz="1100" dirty="0">
+                <a:solidFill>
+                  <a:srgbClr val="E9F1F6"/>
+                </a:solidFill>
+                <a:latin typeface="Courier New" pitchFamily="34" charset="0"/>
+                <a:ea typeface="Courier New" pitchFamily="34" charset="-122"/>
+                <a:cs typeface="Courier New" pitchFamily="34" charset="-120"/>
+              </a:rPr>
+              <a:t>├── 05 SOPs/</a:t>
+            </a:r>
+            <a:endParaRPr lang="en-US" sz="1100" dirty="0"/>
+          </a:p>
+          <a:p>
+            <a:pPr indent="0" marL="0">
+              <a:lnSpc>
+                <a:spcPct val="112000"/>
+              </a:lnSpc>
+              <a:buNone/>
+            </a:pPr>
+            <a:r>
+              <a:rPr lang="en-US" sz="1100" dirty="0">
+                <a:solidFill>
+                  <a:srgbClr val="E9F1F6"/>
+                </a:solidFill>
+                <a:latin typeface="Courier New" pitchFamily="34" charset="0"/>
+                <a:ea typeface="Courier New" pitchFamily="34" charset="-122"/>
+                <a:cs typeface="Courier New" pitchFamily="34" charset="-120"/>
+              </a:rPr>
+              <a:t>│   ├── Project Kickoff/</a:t>
+            </a:r>
+            <a:endParaRPr lang="en-US" sz="1100" dirty="0"/>
+          </a:p>
+          <a:p>
+            <a:pPr indent="0" marL="0">
+              <a:lnSpc>
+                <a:spcPct val="112000"/>
+              </a:lnSpc>
+              <a:buNone/>
+            </a:pPr>
+            <a:r>
+              <a:rPr lang="en-US" sz="1100" dirty="0">
+                <a:solidFill>
+                  <a:srgbClr val="E9F1F6"/>
+                </a:solidFill>
+                <a:latin typeface="Courier New" pitchFamily="34" charset="0"/>
+                <a:ea typeface="Courier New" pitchFamily="34" charset="-122"/>
+                <a:cs typeface="Courier New" pitchFamily="34" charset="-120"/>
+              </a:rPr>
+              <a:t>│   ├── QA-QC Review/</a:t>
+            </a:r>
+            <a:endParaRPr lang="en-US" sz="1100" dirty="0"/>
+          </a:p>
+          <a:p>
+            <a:pPr indent="0" marL="0">
+              <a:lnSpc>
+                <a:spcPct val="112000"/>
+              </a:lnSpc>
+              <a:buNone/>
+            </a:pPr>
+            <a:r>
+              <a:rPr lang="en-US" sz="1100" dirty="0">
+                <a:solidFill>
+                  <a:srgbClr val="E9F1F6"/>
+                </a:solidFill>
+                <a:latin typeface="Courier New" pitchFamily="34" charset="0"/>
+                <a:ea typeface="Courier New" pitchFamily="34" charset="-122"/>
+                <a:cs typeface="Courier New" pitchFamily="34" charset="-120"/>
+              </a:rPr>
+              <a:t>│   ├── Submittal Review/</a:t>
+            </a:r>
+            <a:endParaRPr lang="en-US" sz="1100" dirty="0"/>
+          </a:p>
+          <a:p>
+            <a:pPr indent="0" marL="0">
+              <a:lnSpc>
+                <a:spcPct val="112000"/>
+              </a:lnSpc>
+              <a:buNone/>
+            </a:pPr>
+            <a:r>
+              <a:rPr lang="en-US" sz="1100" dirty="0">
+                <a:solidFill>
+                  <a:srgbClr val="E9F1F6"/>
+                </a:solidFill>
+                <a:latin typeface="Courier New" pitchFamily="34" charset="0"/>
+                <a:ea typeface="Courier New" pitchFamily="34" charset="-122"/>
+                <a:cs typeface="Courier New" pitchFamily="34" charset="-120"/>
+              </a:rPr>
+              <a:t>│   ├── Client Onboarding/</a:t>
+            </a:r>
+            <a:endParaRPr lang="en-US" sz="1100" dirty="0"/>
+          </a:p>
+          <a:p>
+            <a:pPr indent="0" marL="0">
+              <a:lnSpc>
+                <a:spcPct val="112000"/>
+              </a:lnSpc>
+              <a:buNone/>
+            </a:pPr>
+            <a:r>
+              <a:rPr lang="en-US" sz="1100" dirty="0">
+                <a:solidFill>
+                  <a:srgbClr val="E9F1F6"/>
+                </a:solidFill>
+                <a:latin typeface="Courier New" pitchFamily="34" charset="0"/>
+                <a:ea typeface="Courier New" pitchFamily="34" charset="-122"/>
+                <a:cs typeface="Courier New" pitchFamily="34" charset="-120"/>
+              </a:rPr>
+              <a:t>│   └── File Backup &amp; Archiving/</a:t>
+            </a:r>
+            <a:endParaRPr lang="en-US" sz="1100" dirty="0"/>
+          </a:p>
+          <a:p>
+            <a:pPr indent="0" marL="0">
+              <a:lnSpc>
+                <a:spcPct val="112000"/>
+              </a:lnSpc>
+              <a:buNone/>
+            </a:pPr>
+            <a:r>
+              <a:rPr lang="en-US" sz="1100" dirty="0">
+                <a:solidFill>
+                  <a:srgbClr val="E9F1F6"/>
+                </a:solidFill>
+                <a:latin typeface="Courier New" pitchFamily="34" charset="0"/>
+                <a:ea typeface="Courier New" pitchFamily="34" charset="-122"/>
+                <a:cs typeface="Courier New" pitchFamily="34" charset="-120"/>
+              </a:rPr>
+              <a:t>└── 06 Revit Standards/</a:t>
+            </a:r>
+            <a:endParaRPr lang="en-US" sz="1100" dirty="0"/>
+          </a:p>
+          <a:p>
+            <a:pPr indent="0" marL="0">
+              <a:lnSpc>
+                <a:spcPct val="112000"/>
+              </a:lnSpc>
+              <a:buNone/>
+            </a:pPr>
+            <a:r>
+              <a:rPr lang="en-US" sz="1100" dirty="0">
+                <a:solidFill>
+                  <a:srgbClr val="E9F1F6"/>
+                </a:solidFill>
+                <a:latin typeface="Courier New" pitchFamily="34" charset="0"/>
+                <a:ea typeface="Courier New" pitchFamily="34" charset="-122"/>
+                <a:cs typeface="Courier New" pitchFamily="34" charset="-120"/>
+              </a:rPr>
+              <a:t>    (no subfolders — flat)</a:t>
+            </a:r>
+            <a:endParaRPr lang="en-US" sz="1100" dirty="0"/>
+          </a:p>
+        </p:txBody>
+      </p:sp>
+      <p:sp>
+        <p:nvSpPr>
+          <p:cNvPr id="8" name="Shape 6"/>
+          <p:cNvSpPr/>
+          <p:nvPr/>
+        </p:nvSpPr>
+        <p:spPr>
+          <a:xfrm>
+            <a:off x="6903720" y="1874520"/>
+            <a:ext cx="4526280" cy="4617720"/>
+          </a:xfrm>
+          <a:prstGeom prst="roundRect">
+            <a:avLst>
+              <a:gd name="adj" fmla="val 1212"/>
+            </a:avLst>
+          </a:prstGeom>
+          <a:solidFill>
+            <a:srgbClr val="0F2A46"/>
+          </a:solidFill>
+          <a:ln w="12700">
+            <a:solidFill>
+              <a:srgbClr val="C1432A"/>
+            </a:solidFill>
+            <a:prstDash val="solid"/>
+          </a:ln>
+        </p:spPr>
+      </p:sp>
+      <p:sp>
+        <p:nvSpPr>
+          <p:cNvPr id="9" name="Text 7"/>
+          <p:cNvSpPr txBox="1"/>
+          <p:nvPr/>
+        </p:nvSpPr>
+        <p:spPr>
+          <a:xfrm>
+            <a:off x="7132320" y="2029968"/>
+            <a:ext cx="4114800" cy="219456"/>
+          </a:xfrm>
+          <a:prstGeom prst="rect">
+            <a:avLst/>
+          </a:prstGeom>
+          <a:noFill/>
+          <a:ln/>
+        </p:spPr>
+        <p:txBody>
+          <a:bodyPr wrap="square" lIns="0" tIns="0" rIns="0" bIns="0" rtlCol="0" anchor="ctr"/>
+          <a:lstStyle/>
+          <a:p>
+            <a:pPr indent="0" marL="0">
+              <a:buNone/>
+            </a:pPr>
+            <a:r>
+              <a:rPr lang="en-US" sz="900" spc="60" kern="0" dirty="0">
+                <a:solidFill>
+                  <a:srgbClr val="C1432A"/>
+                </a:solidFill>
+                <a:latin typeface="Courier New" pitchFamily="34" charset="0"/>
+                <a:ea typeface="Courier New" pitchFamily="34" charset="-122"/>
+                <a:cs typeface="Courier New" pitchFamily="34" charset="-120"/>
+              </a:rPr>
+              <a:t>LEARNING SESSIONS — GROUPED BY MONTH</a:t>
+            </a:r>
+            <a:endParaRPr lang="en-US" sz="900" dirty="0"/>
+          </a:p>
+        </p:txBody>
+      </p:sp>
+      <p:sp>
+        <p:nvSpPr>
+          <p:cNvPr id="10" name="Text 8"/>
+          <p:cNvSpPr txBox="1"/>
+          <p:nvPr/>
+        </p:nvSpPr>
+        <p:spPr>
+          <a:xfrm>
+            <a:off x="7132320" y="2304288"/>
+            <a:ext cx="4114800" cy="3108960"/>
+          </a:xfrm>
+          <a:prstGeom prst="rect">
+            <a:avLst/>
+          </a:prstGeom>
+          <a:noFill/>
+          <a:ln/>
+        </p:spPr>
+        <p:txBody>
+          <a:bodyPr wrap="square" lIns="0" tIns="0" rIns="0" bIns="0" rtlCol="0" anchor="t"/>
+          <a:lstStyle/>
+          <a:p>
+            <a:pPr indent="0" marL="0">
+              <a:lnSpc>
+                <a:spcPct val="112000"/>
+              </a:lnSpc>
+              <a:buNone/>
+            </a:pPr>
+            <a:r>
+              <a:rPr lang="en-US" sz="1100" dirty="0">
+                <a:solidFill>
+                  <a:srgbClr val="E9F1F6"/>
+                </a:solidFill>
+                <a:latin typeface="Courier New" pitchFamily="34" charset="0"/>
+                <a:ea typeface="Courier New" pitchFamily="34" charset="-122"/>
+                <a:cs typeface="Courier New" pitchFamily="34" charset="-120"/>
+              </a:rPr>
+              <a:t>08 Learning Sessions/</a:t>
+            </a:r>
+            <a:endParaRPr lang="en-US" sz="1100" dirty="0"/>
+          </a:p>
+          <a:p>
+            <a:pPr indent="0" marL="0">
+              <a:lnSpc>
+                <a:spcPct val="112000"/>
+              </a:lnSpc>
+              <a:buNone/>
+            </a:pPr>
+            <a:r>
+              <a:rPr lang="en-US" sz="1100" dirty="0">
+                <a:solidFill>
+                  <a:srgbClr val="E9F1F6"/>
+                </a:solidFill>
+                <a:latin typeface="Courier New" pitchFamily="34" charset="0"/>
+                <a:ea typeface="Courier New" pitchFamily="34" charset="-122"/>
+                <a:cs typeface="Courier New" pitchFamily="34" charset="-120"/>
+              </a:rPr>
+              <a:t>├── September 2026/</a:t>
+            </a:r>
+            <a:endParaRPr lang="en-US" sz="1100" dirty="0"/>
+          </a:p>
+          <a:p>
+            <a:pPr indent="0" marL="0">
+              <a:lnSpc>
+                <a:spcPct val="112000"/>
+              </a:lnSpc>
+              <a:buNone/>
+            </a:pPr>
+            <a:r>
+              <a:rPr lang="en-US" sz="1100" dirty="0">
+                <a:solidFill>
+                  <a:srgbClr val="E9F1F6"/>
+                </a:solidFill>
+                <a:latin typeface="Courier New" pitchFamily="34" charset="0"/>
+                <a:ea typeface="Courier New" pitchFamily="34" charset="-122"/>
+                <a:cs typeface="Courier New" pitchFamily="34" charset="-120"/>
+              </a:rPr>
+              <a:t>│   ├── 2026-09-04_Revit Keynoting Tips/</a:t>
+            </a:r>
+            <a:endParaRPr lang="en-US" sz="1100" dirty="0"/>
+          </a:p>
+          <a:p>
+            <a:pPr indent="0" marL="0">
+              <a:lnSpc>
+                <a:spcPct val="112000"/>
+              </a:lnSpc>
+              <a:buNone/>
+            </a:pPr>
+            <a:r>
+              <a:rPr lang="en-US" sz="1100" dirty="0">
+                <a:solidFill>
+                  <a:srgbClr val="E9F1F6"/>
+                </a:solidFill>
+                <a:latin typeface="Courier New" pitchFamily="34" charset="0"/>
+                <a:ea typeface="Courier New" pitchFamily="34" charset="-122"/>
+                <a:cs typeface="Courier New" pitchFamily="34" charset="-120"/>
+              </a:rPr>
+              <a:t>│   ├── 2026-09-11_Title of Learning Session/</a:t>
+            </a:r>
+            <a:endParaRPr lang="en-US" sz="1100" dirty="0"/>
+          </a:p>
+          <a:p>
+            <a:pPr indent="0" marL="0">
+              <a:lnSpc>
+                <a:spcPct val="112000"/>
+              </a:lnSpc>
+              <a:buNone/>
+            </a:pPr>
+            <a:r>
+              <a:rPr lang="en-US" sz="1100" dirty="0">
+                <a:solidFill>
+                  <a:srgbClr val="E9F1F6"/>
+                </a:solidFill>
+                <a:latin typeface="Courier New" pitchFamily="34" charset="0"/>
+                <a:ea typeface="Courier New" pitchFamily="34" charset="-122"/>
+                <a:cs typeface="Courier New" pitchFamily="34" charset="-120"/>
+              </a:rPr>
+              <a:t>│   └── 2026-09-18_Title of Learning Session/</a:t>
+            </a:r>
+            <a:endParaRPr lang="en-US" sz="1100" dirty="0"/>
+          </a:p>
+          <a:p>
+            <a:pPr indent="0" marL="0">
+              <a:lnSpc>
+                <a:spcPct val="112000"/>
+              </a:lnSpc>
+              <a:buNone/>
+            </a:pPr>
+            <a:r>
+              <a:rPr lang="en-US" sz="1100" dirty="0">
+                <a:solidFill>
+                  <a:srgbClr val="E9F1F6"/>
+                </a:solidFill>
+                <a:latin typeface="Courier New" pitchFamily="34" charset="0"/>
+                <a:ea typeface="Courier New" pitchFamily="34" charset="-122"/>
+                <a:cs typeface="Courier New" pitchFamily="34" charset="-120"/>
+              </a:rPr>
+              <a:t>├── October 2026/</a:t>
+            </a:r>
+            <a:endParaRPr lang="en-US" sz="1100" dirty="0"/>
+          </a:p>
+          <a:p>
+            <a:pPr indent="0" marL="0">
+              <a:lnSpc>
+                <a:spcPct val="112000"/>
+              </a:lnSpc>
+              <a:buNone/>
+            </a:pPr>
+            <a:r>
+              <a:rPr lang="en-US" sz="1100" dirty="0">
+                <a:solidFill>
+                  <a:srgbClr val="E9F1F6"/>
+                </a:solidFill>
+                <a:latin typeface="Courier New" pitchFamily="34" charset="0"/>
+                <a:ea typeface="Courier New" pitchFamily="34" charset="-122"/>
+                <a:cs typeface="Courier New" pitchFamily="34" charset="-120"/>
+              </a:rPr>
+              <a:t>│   ├── 2026-10-02_Title of Learning Session/</a:t>
+            </a:r>
+            <a:endParaRPr lang="en-US" sz="1100" dirty="0"/>
+          </a:p>
+          <a:p>
+            <a:pPr indent="0" marL="0">
+              <a:lnSpc>
+                <a:spcPct val="112000"/>
+              </a:lnSpc>
+              <a:buNone/>
+            </a:pPr>
+            <a:r>
+              <a:rPr lang="en-US" sz="1100" dirty="0">
+                <a:solidFill>
+                  <a:srgbClr val="E9F1F6"/>
+                </a:solidFill>
+                <a:latin typeface="Courier New" pitchFamily="34" charset="0"/>
+                <a:ea typeface="Courier New" pitchFamily="34" charset="-122"/>
+                <a:cs typeface="Courier New" pitchFamily="34" charset="-120"/>
+              </a:rPr>
+              <a:t>│   ├── 2026-10-09_Title of Learning Session/</a:t>
+            </a:r>
+            <a:endParaRPr lang="en-US" sz="1100" dirty="0"/>
+          </a:p>
+          <a:p>
+            <a:pPr indent="0" marL="0">
+              <a:lnSpc>
+                <a:spcPct val="112000"/>
+              </a:lnSpc>
+              <a:buNone/>
+            </a:pPr>
+            <a:r>
+              <a:rPr lang="en-US" sz="1100" dirty="0">
+                <a:solidFill>
+                  <a:srgbClr val="E9F1F6"/>
+                </a:solidFill>
+                <a:latin typeface="Courier New" pitchFamily="34" charset="0"/>
+                <a:ea typeface="Courier New" pitchFamily="34" charset="-122"/>
+                <a:cs typeface="Courier New" pitchFamily="34" charset="-120"/>
+              </a:rPr>
+              <a:t>│   ├── 2026-10-16_Title of Learning Session/</a:t>
+            </a:r>
+            <a:endParaRPr lang="en-US" sz="1100" dirty="0"/>
+          </a:p>
+          <a:p>
+            <a:pPr indent="0" marL="0">
+              <a:lnSpc>
+                <a:spcPct val="112000"/>
+              </a:lnSpc>
+              <a:buNone/>
+            </a:pPr>
+            <a:r>
+              <a:rPr lang="en-US" sz="1100" dirty="0">
+                <a:solidFill>
+                  <a:srgbClr val="E9F1F6"/>
+                </a:solidFill>
+                <a:latin typeface="Courier New" pitchFamily="34" charset="0"/>
+                <a:ea typeface="Courier New" pitchFamily="34" charset="-122"/>
+                <a:cs typeface="Courier New" pitchFamily="34" charset="-120"/>
+              </a:rPr>
+              <a:t>│   ├── 2026-10-23_Title of Learning Session/</a:t>
+            </a:r>
+            <a:endParaRPr lang="en-US" sz="1100" dirty="0"/>
+          </a:p>
+          <a:p>
+            <a:pPr indent="0" marL="0">
+              <a:lnSpc>
+                <a:spcPct val="112000"/>
+              </a:lnSpc>
+              <a:buNone/>
+            </a:pPr>
+            <a:r>
+              <a:rPr lang="en-US" sz="1100" dirty="0">
+                <a:solidFill>
+                  <a:srgbClr val="E9F1F6"/>
+                </a:solidFill>
+                <a:latin typeface="Courier New" pitchFamily="34" charset="0"/>
+                <a:ea typeface="Courier New" pitchFamily="34" charset="-122"/>
+                <a:cs typeface="Courier New" pitchFamily="34" charset="-120"/>
+              </a:rPr>
+              <a:t>│   └── 2026-10-30_Title of Learning Session/</a:t>
+            </a:r>
+            <a:endParaRPr lang="en-US" sz="1100" dirty="0"/>
+          </a:p>
+          <a:p>
+            <a:pPr indent="0" marL="0">
+              <a:lnSpc>
+                <a:spcPct val="112000"/>
+              </a:lnSpc>
+              <a:buNone/>
+            </a:pPr>
+            <a:r>
+              <a:rPr lang="en-US" sz="1100" dirty="0">
+                <a:solidFill>
+                  <a:srgbClr val="E9F1F6"/>
+                </a:solidFill>
+                <a:latin typeface="Courier New" pitchFamily="34" charset="0"/>
+                <a:ea typeface="Courier New" pitchFamily="34" charset="-122"/>
+                <a:cs typeface="Courier New" pitchFamily="34" charset="-120"/>
+              </a:rPr>
+              <a:t>└── November 2026/</a:t>
+            </a:r>
+            <a:endParaRPr lang="en-US" sz="1100" dirty="0"/>
+          </a:p>
+          <a:p>
+            <a:pPr indent="0" marL="0">
+              <a:lnSpc>
+                <a:spcPct val="112000"/>
+              </a:lnSpc>
+              <a:buNone/>
+            </a:pPr>
+            <a:r>
+              <a:rPr lang="en-US" sz="1100" dirty="0">
+                <a:solidFill>
+                  <a:srgbClr val="E9F1F6"/>
+                </a:solidFill>
+                <a:latin typeface="Courier New" pitchFamily="34" charset="0"/>
+                <a:ea typeface="Courier New" pitchFamily="34" charset="-122"/>
+                <a:cs typeface="Courier New" pitchFamily="34" charset="-120"/>
+              </a:rPr>
+              <a:t>    └── 2026-11-06_Title of Learning Session/</a:t>
+            </a:r>
+            <a:endParaRPr lang="en-US" sz="1100" dirty="0"/>
+          </a:p>
+        </p:txBody>
+      </p:sp>
+      <p:sp>
+        <p:nvSpPr>
+          <p:cNvPr id="11" name="Text 9"/>
+          <p:cNvSpPr txBox="1"/>
+          <p:nvPr/>
+        </p:nvSpPr>
+        <p:spPr>
+          <a:xfrm>
+            <a:off x="7132320" y="5806440"/>
+            <a:ext cx="4114800" cy="457200"/>
+          </a:xfrm>
+          <a:prstGeom prst="rect">
+            <a:avLst/>
+          </a:prstGeom>
+          <a:noFill/>
+          <a:ln/>
+        </p:spPr>
+        <p:txBody>
+          <a:bodyPr wrap="square" lIns="0" tIns="0" rIns="0" bIns="0" rtlCol="0" anchor="ctr"/>
+          <a:lstStyle/>
+          <a:p>
+            <a:pPr indent="0" marL="0">
+              <a:buNone/>
+            </a:pPr>
+            <a:r>
+              <a:rPr lang="en-US" sz="950" i="1" dirty="0">
+                <a:solidFill>
+                  <a:srgbClr val="A9C0D2"/>
+                </a:solidFill>
+                <a:latin typeface="Calibri" pitchFamily="34" charset="0"/>
+                <a:ea typeface="Calibri" pitchFamily="34" charset="-122"/>
+                <a:cs typeface="Calibri" pitchFamily="34" charset="-120"/>
+              </a:rPr>
+              <a:t>Naming convention: YYYY-MM-DD_Title of Learning Session</a:t>
+            </a:r>
+            <a:endParaRPr lang="en-US" sz="950" dirty="0"/>
+          </a:p>
+        </p:txBody>
+      </p:sp>
+    </p:spTree>
+  </p:cSld>
+  <p:clrMapOvr>
+    <a:masterClrMapping/>
+  </p:clrMapOvr>
+</p:sld>
+</file>
+
 <file path=ppt/slides/slide2.xml><?xml version="1.0" encoding="utf-8"?>
 <p:sld xmlns:a="http://schemas.openxmlformats.org/drawingml/2006/main" xmlns:r="http://schemas.openxmlformats.org/officeDocument/2006/relationships" xmlns:p="http://schemas.openxmlformats.org/presentationml/2006/main">
   <p:cSld name="Slide 2">

</xml_diff>

<commit_message>
Give Home page a bold navy hero band and add Learning Sessions tile
Quick-access tiles now sit on a solid navy band (icon-in-white-circle, white
labels) instead of plain white cards, with Learning Sessions added as a
7th tile. Pinned/Announcement section labels get small colored markers, and
the announcement card uses a light navy-tinted background instead of white,
so the Home page reads as the deck's hero page rather than blending into
the other utility pages.

Co-Authored-By: Claude Sonnet 5 <noreply@anthropic.com>
Claude-Session: https://claude.ai/code/session_01YAQcUYpy57Up3cir28mVUA
</commit_message>
<xml_diff>
--- a/office-hub-concept.pptx
+++ b/office-hub-concept.pptx
@@ -5594,35 +5594,50 @@
         </p:nvSpPr>
         <p:spPr>
           <a:xfrm>
-            <a:off x="2286000" y="1956816"/>
-            <a:ext cx="1475689" cy="987552"/>
+            <a:off x="2139696" y="1920240"/>
+            <a:ext cx="9878263" cy="1344168"/>
           </a:xfrm>
           <a:prstGeom prst="roundRect">
             <a:avLst>
-              <a:gd name="adj" fmla="val 5556"/>
+              <a:gd name="adj" fmla="val 5442"/>
             </a:avLst>
           </a:prstGeom>
           <a:solidFill>
-            <a:srgbClr val="FBFCFC"/>
+            <a:srgbClr val="022049"/>
           </a:solidFill>
-          <a:ln w="12700">
-            <a:solidFill>
-              <a:srgbClr val="C9D1D6"/>
-            </a:solidFill>
-            <a:prstDash val="solid"/>
-          </a:ln>
+          <a:ln/>
           <a:effectLst>
-            <a:outerShdw sx="100000" sy="100000" kx="0" ky="0" algn="bl" rotWithShape="0" blurRad="63500" dist="25400" dir="5400000">
-              <a:srgbClr val="022049">
-                <a:alpha val="14000"/>
+            <a:outerShdw sx="100000" sy="100000" kx="0" ky="0" algn="bl" rotWithShape="0" blurRad="101600" dist="38100" dir="5400000">
+              <a:srgbClr val="000000">
+                <a:alpha val="25000"/>
               </a:srgbClr>
             </a:outerShdw>
           </a:effectLst>
         </p:spPr>
       </p:sp>
+      <p:sp>
+        <p:nvSpPr>
+          <p:cNvPr id="30" name="Shape 28"/>
+          <p:cNvSpPr/>
+          <p:nvPr/>
+        </p:nvSpPr>
+        <p:spPr>
+          <a:xfrm>
+            <a:off x="2678082" y="2176272"/>
+            <a:ext cx="475488" cy="475488"/>
+          </a:xfrm>
+          <a:prstGeom prst="ellipse">
+            <a:avLst/>
+          </a:prstGeom>
+          <a:solidFill>
+            <a:srgbClr val="FFFFFF"/>
+          </a:solidFill>
+          <a:ln/>
+        </p:spPr>
+      </p:sp>
       <p:pic>
         <p:nvPicPr>
-          <p:cNvPr id="30" name="Image 0" descr="/tmp/claude-0/-home-user-drawing-set/4abccc73-5df9-5ad5-9792-19a3f012db48/scratchpad/icons/standards.png">    </p:cNvPr>
+          <p:cNvPr id="31" name="Image 0" descr="/tmp/claude-0/-home-user-drawing-set/4abccc73-5df9-5ad5-9792-19a3f012db48/scratchpad/icons/standards.png">    </p:cNvPr>
           <p:cNvPicPr>
             <a:picLocks noChangeAspect="1"/>
           </p:cNvPicPr>
@@ -5636,8 +5651,8 @@
         </p:blipFill>
         <p:spPr>
           <a:xfrm>
-            <a:off x="2850109" y="2084832"/>
-            <a:ext cx="347472" cy="347472"/>
+            <a:off x="2769522" y="2267712"/>
+            <a:ext cx="292608" cy="292608"/>
           </a:xfrm>
           <a:prstGeom prst="rect">
             <a:avLst/>
@@ -5646,14 +5661,14 @@
       </p:pic>
       <p:sp>
         <p:nvSpPr>
-          <p:cNvPr id="31" name="Text 28"/>
-          <p:cNvSpPr txBox="1"/>
-          <p:nvPr/>
-        </p:nvSpPr>
-        <p:spPr>
-          <a:xfrm>
-            <a:off x="2286000" y="2487168"/>
-            <a:ext cx="1475689" cy="365760"/>
+          <p:cNvPr id="32" name="Text 29"/>
+          <p:cNvSpPr txBox="1"/>
+          <p:nvPr/>
+        </p:nvSpPr>
+        <p:spPr>
+          <a:xfrm>
+            <a:off x="2286000" y="2724912"/>
+            <a:ext cx="1259651" cy="329184"/>
           </a:xfrm>
           <a:prstGeom prst="rect">
             <a:avLst/>
@@ -5669,9 +5684,9 @@
               <a:buNone/>
             </a:pPr>
             <a:r>
-              <a:rPr lang="en-US" sz="950" b="1" dirty="0">
-                <a:solidFill>
-                  <a:srgbClr val="022049"/>
+              <a:rPr lang="en-US" sz="900" b="1" dirty="0">
+                <a:solidFill>
+                  <a:srgbClr val="FFFFFF"/>
                 </a:solidFill>
                 <a:latin typeface="Arial" pitchFamily="34" charset="0"/>
                 <a:ea typeface="Arial" pitchFamily="34" charset="-122"/>
@@ -5679,47 +5694,33 @@
               </a:rPr>
               <a:t>STANDARDS</a:t>
             </a:r>
-            <a:endParaRPr lang="en-US" sz="950" dirty="0"/>
-          </a:p>
-        </p:txBody>
-      </p:sp>
-      <p:sp>
-        <p:nvSpPr>
-          <p:cNvPr id="32" name="Shape 29"/>
+            <a:endParaRPr lang="en-US" sz="900" dirty="0"/>
+          </a:p>
+        </p:txBody>
+      </p:sp>
+      <p:sp>
+        <p:nvSpPr>
+          <p:cNvPr id="33" name="Shape 30"/>
           <p:cNvSpPr/>
           <p:nvPr/>
         </p:nvSpPr>
         <p:spPr>
           <a:xfrm>
-            <a:off x="3907993" y="1956816"/>
-            <a:ext cx="1475689" cy="987552"/>
-          </a:xfrm>
-          <a:prstGeom prst="roundRect">
-            <a:avLst>
-              <a:gd name="adj" fmla="val 5556"/>
-            </a:avLst>
+            <a:off x="4065749" y="2176272"/>
+            <a:ext cx="475488" cy="475488"/>
+          </a:xfrm>
+          <a:prstGeom prst="ellipse">
+            <a:avLst/>
           </a:prstGeom>
           <a:solidFill>
-            <a:srgbClr val="FBFCFC"/>
+            <a:srgbClr val="FFFFFF"/>
           </a:solidFill>
-          <a:ln w="12700">
-            <a:solidFill>
-              <a:srgbClr val="C9D1D6"/>
-            </a:solidFill>
-            <a:prstDash val="solid"/>
-          </a:ln>
-          <a:effectLst>
-            <a:outerShdw sx="100000" sy="100000" kx="0" ky="0" algn="bl" rotWithShape="0" blurRad="63500" dist="25400" dir="5400000">
-              <a:srgbClr val="022049">
-                <a:alpha val="14000"/>
-              </a:srgbClr>
-            </a:outerShdw>
-          </a:effectLst>
+          <a:ln/>
         </p:spPr>
       </p:sp>
       <p:pic>
         <p:nvPicPr>
-          <p:cNvPr id="33" name="Image 1" descr="/tmp/claude-0/-home-user-drawing-set/4abccc73-5df9-5ad5-9792-19a3f012db48/scratchpad/icons/templates.png">    </p:cNvPr>
+          <p:cNvPr id="34" name="Image 1" descr="/tmp/claude-0/-home-user-drawing-set/4abccc73-5df9-5ad5-9792-19a3f012db48/scratchpad/icons/templates.png">    </p:cNvPr>
           <p:cNvPicPr>
             <a:picLocks noChangeAspect="1"/>
           </p:cNvPicPr>
@@ -5733,8 +5734,8 @@
         </p:blipFill>
         <p:spPr>
           <a:xfrm>
-            <a:off x="4472102" y="2084832"/>
-            <a:ext cx="347472" cy="347472"/>
+            <a:off x="4157189" y="2267712"/>
+            <a:ext cx="292608" cy="292608"/>
           </a:xfrm>
           <a:prstGeom prst="rect">
             <a:avLst/>
@@ -5743,14 +5744,14 @@
       </p:pic>
       <p:sp>
         <p:nvSpPr>
-          <p:cNvPr id="34" name="Text 30"/>
-          <p:cNvSpPr txBox="1"/>
-          <p:nvPr/>
-        </p:nvSpPr>
-        <p:spPr>
-          <a:xfrm>
-            <a:off x="3907993" y="2487168"/>
-            <a:ext cx="1475689" cy="365760"/>
+          <p:cNvPr id="35" name="Text 31"/>
+          <p:cNvSpPr txBox="1"/>
+          <p:nvPr/>
+        </p:nvSpPr>
+        <p:spPr>
+          <a:xfrm>
+            <a:off x="3673667" y="2724912"/>
+            <a:ext cx="1259651" cy="329184"/>
           </a:xfrm>
           <a:prstGeom prst="rect">
             <a:avLst/>
@@ -5766,9 +5767,9 @@
               <a:buNone/>
             </a:pPr>
             <a:r>
-              <a:rPr lang="en-US" sz="950" b="1" dirty="0">
-                <a:solidFill>
-                  <a:srgbClr val="022049"/>
+              <a:rPr lang="en-US" sz="900" b="1" dirty="0">
+                <a:solidFill>
+                  <a:srgbClr val="FFFFFF"/>
                 </a:solidFill>
                 <a:latin typeface="Arial" pitchFamily="34" charset="0"/>
                 <a:ea typeface="Arial" pitchFamily="34" charset="-122"/>
@@ -5776,47 +5777,33 @@
               </a:rPr>
               <a:t>TEMPLATES</a:t>
             </a:r>
-            <a:endParaRPr lang="en-US" sz="950" dirty="0"/>
-          </a:p>
-        </p:txBody>
-      </p:sp>
-      <p:sp>
-        <p:nvSpPr>
-          <p:cNvPr id="35" name="Shape 31"/>
+            <a:endParaRPr lang="en-US" sz="900" dirty="0"/>
+          </a:p>
+        </p:txBody>
+      </p:sp>
+      <p:sp>
+        <p:nvSpPr>
+          <p:cNvPr id="36" name="Shape 32"/>
           <p:cNvSpPr/>
           <p:nvPr/>
         </p:nvSpPr>
         <p:spPr>
           <a:xfrm>
-            <a:off x="5529986" y="1956816"/>
-            <a:ext cx="1475689" cy="987552"/>
-          </a:xfrm>
-          <a:prstGeom prst="roundRect">
-            <a:avLst>
-              <a:gd name="adj" fmla="val 5556"/>
-            </a:avLst>
+            <a:off x="5453416" y="2176272"/>
+            <a:ext cx="475488" cy="475488"/>
+          </a:xfrm>
+          <a:prstGeom prst="ellipse">
+            <a:avLst/>
           </a:prstGeom>
           <a:solidFill>
-            <a:srgbClr val="FBFCFC"/>
+            <a:srgbClr val="FFFFFF"/>
           </a:solidFill>
-          <a:ln w="12700">
-            <a:solidFill>
-              <a:srgbClr val="C9D1D6"/>
-            </a:solidFill>
-            <a:prstDash val="solid"/>
-          </a:ln>
-          <a:effectLst>
-            <a:outerShdw sx="100000" sy="100000" kx="0" ky="0" algn="bl" rotWithShape="0" blurRad="63500" dist="25400" dir="5400000">
-              <a:srgbClr val="022049">
-                <a:alpha val="14000"/>
-              </a:srgbClr>
-            </a:outerShdw>
-          </a:effectLst>
+          <a:ln/>
         </p:spPr>
       </p:sp>
       <p:pic>
         <p:nvPicPr>
-          <p:cNvPr id="36" name="Image 2" descr="/tmp/claude-0/-home-user-drawing-set/4abccc73-5df9-5ad5-9792-19a3f012db48/scratchpad/icons/forms.png">    </p:cNvPr>
+          <p:cNvPr id="37" name="Image 2" descr="/tmp/claude-0/-home-user-drawing-set/4abccc73-5df9-5ad5-9792-19a3f012db48/scratchpad/icons/forms.png">    </p:cNvPr>
           <p:cNvPicPr>
             <a:picLocks noChangeAspect="1"/>
           </p:cNvPicPr>
@@ -5830,8 +5817,8 @@
         </p:blipFill>
         <p:spPr>
           <a:xfrm>
-            <a:off x="6094095" y="2084832"/>
-            <a:ext cx="347472" cy="347472"/>
+            <a:off x="5544856" y="2267712"/>
+            <a:ext cx="292608" cy="292608"/>
           </a:xfrm>
           <a:prstGeom prst="rect">
             <a:avLst/>
@@ -5840,14 +5827,14 @@
       </p:pic>
       <p:sp>
         <p:nvSpPr>
-          <p:cNvPr id="37" name="Text 32"/>
-          <p:cNvSpPr txBox="1"/>
-          <p:nvPr/>
-        </p:nvSpPr>
-        <p:spPr>
-          <a:xfrm>
-            <a:off x="5529986" y="2487168"/>
-            <a:ext cx="1475689" cy="365760"/>
+          <p:cNvPr id="38" name="Text 33"/>
+          <p:cNvSpPr txBox="1"/>
+          <p:nvPr/>
+        </p:nvSpPr>
+        <p:spPr>
+          <a:xfrm>
+            <a:off x="5061335" y="2724912"/>
+            <a:ext cx="1259651" cy="329184"/>
           </a:xfrm>
           <a:prstGeom prst="rect">
             <a:avLst/>
@@ -5863,9 +5850,9 @@
               <a:buNone/>
             </a:pPr>
             <a:r>
-              <a:rPr lang="en-US" sz="950" b="1" dirty="0">
-                <a:solidFill>
-                  <a:srgbClr val="022049"/>
+              <a:rPr lang="en-US" sz="900" b="1" dirty="0">
+                <a:solidFill>
+                  <a:srgbClr val="FFFFFF"/>
                 </a:solidFill>
                 <a:latin typeface="Arial" pitchFamily="34" charset="0"/>
                 <a:ea typeface="Arial" pitchFamily="34" charset="-122"/>
@@ -5873,47 +5860,33 @@
               </a:rPr>
               <a:t>FORMS</a:t>
             </a:r>
-            <a:endParaRPr lang="en-US" sz="950" dirty="0"/>
-          </a:p>
-        </p:txBody>
-      </p:sp>
-      <p:sp>
-        <p:nvSpPr>
-          <p:cNvPr id="38" name="Shape 33"/>
+            <a:endParaRPr lang="en-US" sz="900" dirty="0"/>
+          </a:p>
+        </p:txBody>
+      </p:sp>
+      <p:sp>
+        <p:nvSpPr>
+          <p:cNvPr id="39" name="Shape 34"/>
           <p:cNvSpPr/>
           <p:nvPr/>
         </p:nvSpPr>
         <p:spPr>
           <a:xfrm>
-            <a:off x="7151980" y="1956816"/>
-            <a:ext cx="1475689" cy="987552"/>
-          </a:xfrm>
-          <a:prstGeom prst="roundRect">
-            <a:avLst>
-              <a:gd name="adj" fmla="val 5556"/>
-            </a:avLst>
+            <a:off x="6841084" y="2176272"/>
+            <a:ext cx="475488" cy="475488"/>
+          </a:xfrm>
+          <a:prstGeom prst="ellipse">
+            <a:avLst/>
           </a:prstGeom>
           <a:solidFill>
-            <a:srgbClr val="FBFCFC"/>
+            <a:srgbClr val="FFFFFF"/>
           </a:solidFill>
-          <a:ln w="12700">
-            <a:solidFill>
-              <a:srgbClr val="C9D1D6"/>
-            </a:solidFill>
-            <a:prstDash val="solid"/>
-          </a:ln>
-          <a:effectLst>
-            <a:outerShdw sx="100000" sy="100000" kx="0" ky="0" algn="bl" rotWithShape="0" blurRad="63500" dist="25400" dir="5400000">
-              <a:srgbClr val="022049">
-                <a:alpha val="14000"/>
-              </a:srgbClr>
-            </a:outerShdw>
-          </a:effectLst>
+          <a:ln/>
         </p:spPr>
       </p:sp>
       <p:pic>
         <p:nvPicPr>
-          <p:cNvPr id="39" name="Image 3" descr="/tmp/claude-0/-home-user-drawing-set/4abccc73-5df9-5ad5-9792-19a3f012db48/scratchpad/icons/policies.png">    </p:cNvPr>
+          <p:cNvPr id="40" name="Image 3" descr="/tmp/claude-0/-home-user-drawing-set/4abccc73-5df9-5ad5-9792-19a3f012db48/scratchpad/icons/policies.png">    </p:cNvPr>
           <p:cNvPicPr>
             <a:picLocks noChangeAspect="1"/>
           </p:cNvPicPr>
@@ -5927,8 +5900,8 @@
         </p:blipFill>
         <p:spPr>
           <a:xfrm>
-            <a:off x="7716088" y="2084832"/>
-            <a:ext cx="347472" cy="347472"/>
+            <a:off x="6932524" y="2267712"/>
+            <a:ext cx="292608" cy="292608"/>
           </a:xfrm>
           <a:prstGeom prst="rect">
             <a:avLst/>
@@ -5937,14 +5910,14 @@
       </p:pic>
       <p:sp>
         <p:nvSpPr>
-          <p:cNvPr id="40" name="Text 34"/>
-          <p:cNvSpPr txBox="1"/>
-          <p:nvPr/>
-        </p:nvSpPr>
-        <p:spPr>
-          <a:xfrm>
-            <a:off x="7151980" y="2487168"/>
-            <a:ext cx="1475689" cy="365760"/>
+          <p:cNvPr id="41" name="Text 35"/>
+          <p:cNvSpPr txBox="1"/>
+          <p:nvPr/>
+        </p:nvSpPr>
+        <p:spPr>
+          <a:xfrm>
+            <a:off x="6449002" y="2724912"/>
+            <a:ext cx="1259651" cy="329184"/>
           </a:xfrm>
           <a:prstGeom prst="rect">
             <a:avLst/>
@@ -5960,9 +5933,9 @@
               <a:buNone/>
             </a:pPr>
             <a:r>
-              <a:rPr lang="en-US" sz="950" b="1" dirty="0">
-                <a:solidFill>
-                  <a:srgbClr val="022049"/>
+              <a:rPr lang="en-US" sz="900" b="1" dirty="0">
+                <a:solidFill>
+                  <a:srgbClr val="FFFFFF"/>
                 </a:solidFill>
                 <a:latin typeface="Arial" pitchFamily="34" charset="0"/>
                 <a:ea typeface="Arial" pitchFamily="34" charset="-122"/>
@@ -5970,47 +5943,33 @@
               </a:rPr>
               <a:t>POLICIES</a:t>
             </a:r>
-            <a:endParaRPr lang="en-US" sz="950" dirty="0"/>
-          </a:p>
-        </p:txBody>
-      </p:sp>
-      <p:sp>
-        <p:nvSpPr>
-          <p:cNvPr id="41" name="Shape 35"/>
+            <a:endParaRPr lang="en-US" sz="900" dirty="0"/>
+          </a:p>
+        </p:txBody>
+      </p:sp>
+      <p:sp>
+        <p:nvSpPr>
+          <p:cNvPr id="42" name="Shape 36"/>
           <p:cNvSpPr/>
           <p:nvPr/>
         </p:nvSpPr>
         <p:spPr>
           <a:xfrm>
-            <a:off x="8773973" y="1956816"/>
-            <a:ext cx="1475689" cy="987552"/>
-          </a:xfrm>
-          <a:prstGeom prst="roundRect">
-            <a:avLst>
-              <a:gd name="adj" fmla="val 5556"/>
-            </a:avLst>
+            <a:off x="8228751" y="2176272"/>
+            <a:ext cx="475488" cy="475488"/>
+          </a:xfrm>
+          <a:prstGeom prst="ellipse">
+            <a:avLst/>
           </a:prstGeom>
           <a:solidFill>
-            <a:srgbClr val="FBFCFC"/>
+            <a:srgbClr val="FFFFFF"/>
           </a:solidFill>
-          <a:ln w="12700">
-            <a:solidFill>
-              <a:srgbClr val="C9D1D6"/>
-            </a:solidFill>
-            <a:prstDash val="solid"/>
-          </a:ln>
-          <a:effectLst>
-            <a:outerShdw sx="100000" sy="100000" kx="0" ky="0" algn="bl" rotWithShape="0" blurRad="63500" dist="25400" dir="5400000">
-              <a:srgbClr val="022049">
-                <a:alpha val="14000"/>
-              </a:srgbClr>
-            </a:outerShdw>
-          </a:effectLst>
+          <a:ln/>
         </p:spPr>
       </p:sp>
       <p:pic>
         <p:nvPicPr>
-          <p:cNvPr id="42" name="Image 4" descr="/tmp/claude-0/-home-user-drawing-set/4abccc73-5df9-5ad5-9792-19a3f012db48/scratchpad/icons/sops.png">    </p:cNvPr>
+          <p:cNvPr id="43" name="Image 4" descr="/tmp/claude-0/-home-user-drawing-set/4abccc73-5df9-5ad5-9792-19a3f012db48/scratchpad/icons/sops.png">    </p:cNvPr>
           <p:cNvPicPr>
             <a:picLocks noChangeAspect="1"/>
           </p:cNvPicPr>
@@ -6024,8 +5983,8 @@
         </p:blipFill>
         <p:spPr>
           <a:xfrm>
-            <a:off x="9338081" y="2084832"/>
-            <a:ext cx="347472" cy="347472"/>
+            <a:off x="8320191" y="2267712"/>
+            <a:ext cx="292608" cy="292608"/>
           </a:xfrm>
           <a:prstGeom prst="rect">
             <a:avLst/>
@@ -6034,14 +5993,14 @@
       </p:pic>
       <p:sp>
         <p:nvSpPr>
-          <p:cNvPr id="43" name="Text 36"/>
-          <p:cNvSpPr txBox="1"/>
-          <p:nvPr/>
-        </p:nvSpPr>
-        <p:spPr>
-          <a:xfrm>
-            <a:off x="8773973" y="2487168"/>
-            <a:ext cx="1475689" cy="365760"/>
+          <p:cNvPr id="44" name="Text 37"/>
+          <p:cNvSpPr txBox="1"/>
+          <p:nvPr/>
+        </p:nvSpPr>
+        <p:spPr>
+          <a:xfrm>
+            <a:off x="7836669" y="2724912"/>
+            <a:ext cx="1259651" cy="329184"/>
           </a:xfrm>
           <a:prstGeom prst="rect">
             <a:avLst/>
@@ -6057,9 +6016,9 @@
               <a:buNone/>
             </a:pPr>
             <a:r>
-              <a:rPr lang="en-US" sz="950" b="1" dirty="0">
-                <a:solidFill>
-                  <a:srgbClr val="022049"/>
+              <a:rPr lang="en-US" sz="900" b="1" dirty="0">
+                <a:solidFill>
+                  <a:srgbClr val="FFFFFF"/>
                 </a:solidFill>
                 <a:latin typeface="Arial" pitchFamily="34" charset="0"/>
                 <a:ea typeface="Arial" pitchFamily="34" charset="-122"/>
@@ -6067,47 +6026,33 @@
               </a:rPr>
               <a:t>SOPS</a:t>
             </a:r>
-            <a:endParaRPr lang="en-US" sz="950" dirty="0"/>
-          </a:p>
-        </p:txBody>
-      </p:sp>
-      <p:sp>
-        <p:nvSpPr>
-          <p:cNvPr id="44" name="Shape 37"/>
+            <a:endParaRPr lang="en-US" sz="900" dirty="0"/>
+          </a:p>
+        </p:txBody>
+      </p:sp>
+      <p:sp>
+        <p:nvSpPr>
+          <p:cNvPr id="45" name="Shape 38"/>
           <p:cNvSpPr/>
           <p:nvPr/>
         </p:nvSpPr>
         <p:spPr>
           <a:xfrm>
-            <a:off x="10395966" y="1956816"/>
-            <a:ext cx="1475689" cy="987552"/>
-          </a:xfrm>
-          <a:prstGeom prst="roundRect">
-            <a:avLst>
-              <a:gd name="adj" fmla="val 5556"/>
-            </a:avLst>
+            <a:off x="9616418" y="2176272"/>
+            <a:ext cx="475488" cy="475488"/>
+          </a:xfrm>
+          <a:prstGeom prst="ellipse">
+            <a:avLst/>
           </a:prstGeom>
           <a:solidFill>
-            <a:srgbClr val="FBFCFC"/>
+            <a:srgbClr val="FFFFFF"/>
           </a:solidFill>
-          <a:ln w="12700">
-            <a:solidFill>
-              <a:srgbClr val="C9D1D6"/>
-            </a:solidFill>
-            <a:prstDash val="solid"/>
-          </a:ln>
-          <a:effectLst>
-            <a:outerShdw sx="100000" sy="100000" kx="0" ky="0" algn="bl" rotWithShape="0" blurRad="63500" dist="25400" dir="5400000">
-              <a:srgbClr val="022049">
-                <a:alpha val="14000"/>
-              </a:srgbClr>
-            </a:outerShdw>
-          </a:effectLst>
+          <a:ln/>
         </p:spPr>
       </p:sp>
       <p:pic>
         <p:nvPicPr>
-          <p:cNvPr id="45" name="Image 5" descr="/tmp/claude-0/-home-user-drawing-set/4abccc73-5df9-5ad5-9792-19a3f012db48/scratchpad/icons/revit.png">    </p:cNvPr>
+          <p:cNvPr id="46" name="Image 5" descr="/tmp/claude-0/-home-user-drawing-set/4abccc73-5df9-5ad5-9792-19a3f012db48/scratchpad/icons/revit.png">    </p:cNvPr>
           <p:cNvPicPr>
             <a:picLocks noChangeAspect="1"/>
           </p:cNvPicPr>
@@ -6121,8 +6066,8 @@
         </p:blipFill>
         <p:spPr>
           <a:xfrm>
-            <a:off x="10960075" y="2084832"/>
-            <a:ext cx="347472" cy="347472"/>
+            <a:off x="9707858" y="2267712"/>
+            <a:ext cx="292608" cy="292608"/>
           </a:xfrm>
           <a:prstGeom prst="rect">
             <a:avLst/>
@@ -6131,14 +6076,14 @@
       </p:pic>
       <p:sp>
         <p:nvSpPr>
-          <p:cNvPr id="46" name="Text 38"/>
-          <p:cNvSpPr txBox="1"/>
-          <p:nvPr/>
-        </p:nvSpPr>
-        <p:spPr>
-          <a:xfrm>
-            <a:off x="10395966" y="2487168"/>
-            <a:ext cx="1475689" cy="365760"/>
+          <p:cNvPr id="47" name="Text 39"/>
+          <p:cNvSpPr txBox="1"/>
+          <p:nvPr/>
+        </p:nvSpPr>
+        <p:spPr>
+          <a:xfrm>
+            <a:off x="9224337" y="2724912"/>
+            <a:ext cx="1259651" cy="329184"/>
           </a:xfrm>
           <a:prstGeom prst="rect">
             <a:avLst/>
@@ -6154,9 +6099,9 @@
               <a:buNone/>
             </a:pPr>
             <a:r>
-              <a:rPr lang="en-US" sz="950" b="1" dirty="0">
-                <a:solidFill>
-                  <a:srgbClr val="022049"/>
+              <a:rPr lang="en-US" sz="900" b="1" dirty="0">
+                <a:solidFill>
+                  <a:srgbClr val="FFFFFF"/>
                 </a:solidFill>
                 <a:latin typeface="Arial" pitchFamily="34" charset="0"/>
                 <a:ea typeface="Arial" pitchFamily="34" charset="-122"/>
@@ -6164,19 +6109,122 @@
               </a:rPr>
               <a:t>REVIT STD.</a:t>
             </a:r>
-            <a:endParaRPr lang="en-US" sz="950" dirty="0"/>
-          </a:p>
-        </p:txBody>
-      </p:sp>
-      <p:sp>
-        <p:nvSpPr>
-          <p:cNvPr id="47" name="Text 39"/>
-          <p:cNvSpPr txBox="1"/>
-          <p:nvPr/>
-        </p:nvSpPr>
-        <p:spPr>
-          <a:xfrm>
-            <a:off x="2286000" y="3163824"/>
+            <a:endParaRPr lang="en-US" sz="900" dirty="0"/>
+          </a:p>
+        </p:txBody>
+      </p:sp>
+      <p:sp>
+        <p:nvSpPr>
+          <p:cNvPr id="48" name="Shape 40"/>
+          <p:cNvSpPr/>
+          <p:nvPr/>
+        </p:nvSpPr>
+        <p:spPr>
+          <a:xfrm>
+            <a:off x="11004086" y="2176272"/>
+            <a:ext cx="475488" cy="475488"/>
+          </a:xfrm>
+          <a:prstGeom prst="ellipse">
+            <a:avLst/>
+          </a:prstGeom>
+          <a:solidFill>
+            <a:srgbClr val="FFFFFF"/>
+          </a:solidFill>
+          <a:ln/>
+        </p:spPr>
+      </p:sp>
+      <p:pic>
+        <p:nvPicPr>
+          <p:cNvPr id="49" name="Image 6" descr="/tmp/claude-0/-home-user-drawing-set/4abccc73-5df9-5ad5-9792-19a3f012db48/scratchpad/icons/learning.png">    </p:cNvPr>
+          <p:cNvPicPr>
+            <a:picLocks noChangeAspect="1"/>
+          </p:cNvPicPr>
+          <p:nvPr/>
+        </p:nvPicPr>
+        <p:blipFill>
+          <a:blip r:embed="rId8"/>
+          <a:stretch>
+            <a:fillRect/>
+          </a:stretch>
+        </p:blipFill>
+        <p:spPr>
+          <a:xfrm>
+            <a:off x="11095526" y="2267712"/>
+            <a:ext cx="292608" cy="292608"/>
+          </a:xfrm>
+          <a:prstGeom prst="rect">
+            <a:avLst/>
+          </a:prstGeom>
+        </p:spPr>
+      </p:pic>
+      <p:sp>
+        <p:nvSpPr>
+          <p:cNvPr id="50" name="Text 41"/>
+          <p:cNvSpPr txBox="1"/>
+          <p:nvPr/>
+        </p:nvSpPr>
+        <p:spPr>
+          <a:xfrm>
+            <a:off x="10612004" y="2724912"/>
+            <a:ext cx="1259651" cy="329184"/>
+          </a:xfrm>
+          <a:prstGeom prst="rect">
+            <a:avLst/>
+          </a:prstGeom>
+          <a:noFill/>
+          <a:ln/>
+        </p:spPr>
+        <p:txBody>
+          <a:bodyPr wrap="square" lIns="0" tIns="0" rIns="0" bIns="0" rtlCol="0" anchor="t"/>
+          <a:lstStyle/>
+          <a:p>
+            <a:pPr algn="ctr" indent="0" marL="0">
+              <a:buNone/>
+            </a:pPr>
+            <a:r>
+              <a:rPr lang="en-US" sz="900" b="1" dirty="0">
+                <a:solidFill>
+                  <a:srgbClr val="FFFFFF"/>
+                </a:solidFill>
+                <a:latin typeface="Arial" pitchFamily="34" charset="0"/>
+                <a:ea typeface="Arial" pitchFamily="34" charset="-122"/>
+                <a:cs typeface="Arial" pitchFamily="34" charset="-120"/>
+              </a:rPr>
+              <a:t>LEARNING</a:t>
+            </a:r>
+            <a:endParaRPr lang="en-US" sz="900" dirty="0"/>
+          </a:p>
+        </p:txBody>
+      </p:sp>
+      <p:sp>
+        <p:nvSpPr>
+          <p:cNvPr id="51" name="Shape 42"/>
+          <p:cNvSpPr/>
+          <p:nvPr/>
+        </p:nvSpPr>
+        <p:spPr>
+          <a:xfrm>
+            <a:off x="2286000" y="3520440"/>
+            <a:ext cx="109728" cy="109728"/>
+          </a:xfrm>
+          <a:prstGeom prst="rect">
+            <a:avLst/>
+          </a:prstGeom>
+          <a:solidFill>
+            <a:srgbClr val="022049"/>
+          </a:solidFill>
+          <a:ln/>
+        </p:spPr>
+      </p:sp>
+      <p:sp>
+        <p:nvSpPr>
+          <p:cNvPr id="52" name="Text 43"/>
+          <p:cNvSpPr txBox="1"/>
+          <p:nvPr/>
+        </p:nvSpPr>
+        <p:spPr>
+          <a:xfrm>
+            <a:off x="2468880" y="3502152"/>
             <a:ext cx="3657600" cy="219456"/>
           </a:xfrm>
           <a:prstGeom prst="rect">
@@ -6195,7 +6243,7 @@
             <a:r>
               <a:rPr lang="en-US" sz="900" spc="100" kern="0" dirty="0">
                 <a:solidFill>
-                  <a:srgbClr val="4B4B4B"/>
+                  <a:srgbClr val="022049"/>
                 </a:solidFill>
                 <a:latin typeface="Courier New" pitchFamily="34" charset="0"/>
                 <a:ea typeface="Courier New" pitchFamily="34" charset="-122"/>
@@ -6209,18 +6257,18 @@
       </p:sp>
       <p:sp>
         <p:nvSpPr>
-          <p:cNvPr id="48" name="Shape 40"/>
+          <p:cNvPr id="53" name="Shape 44"/>
           <p:cNvSpPr/>
           <p:nvPr/>
         </p:nvSpPr>
         <p:spPr>
           <a:xfrm>
-            <a:off x="2286000" y="3438144"/>
-            <a:ext cx="3048914" cy="1737360"/>
+            <a:off x="2286000" y="3776472"/>
+            <a:ext cx="3048914" cy="1554480"/>
           </a:xfrm>
           <a:prstGeom prst="roundRect">
             <a:avLst>
-              <a:gd name="adj" fmla="val 2632"/>
+              <a:gd name="adj" fmla="val 2941"/>
             </a:avLst>
           </a:prstGeom>
           <a:solidFill>
@@ -6243,13 +6291,13 @@
       </p:sp>
       <p:sp>
         <p:nvSpPr>
-          <p:cNvPr id="49" name="Text 41"/>
-          <p:cNvSpPr txBox="1"/>
-          <p:nvPr/>
-        </p:nvSpPr>
-        <p:spPr>
-          <a:xfrm>
-            <a:off x="2414016" y="3529584"/>
+          <p:cNvPr id="54" name="Text 45"/>
+          <p:cNvSpPr txBox="1"/>
+          <p:nvPr/>
+        </p:nvSpPr>
+        <p:spPr>
+          <a:xfrm>
+            <a:off x="2414016" y="3867912"/>
             <a:ext cx="1676903" cy="182880"/>
           </a:xfrm>
           <a:prstGeom prst="rect">
@@ -6282,13 +6330,13 @@
       </p:sp>
       <p:sp>
         <p:nvSpPr>
-          <p:cNvPr id="50" name="Shape 42"/>
+          <p:cNvPr id="55" name="Shape 46"/>
           <p:cNvSpPr/>
           <p:nvPr/>
         </p:nvSpPr>
         <p:spPr>
           <a:xfrm>
-            <a:off x="4621682" y="3520440"/>
+            <a:off x="4621682" y="3858768"/>
             <a:ext cx="621792" cy="173736"/>
           </a:xfrm>
           <a:prstGeom prst="roundRect">
@@ -6309,13 +6357,13 @@
       </p:sp>
       <p:sp>
         <p:nvSpPr>
-          <p:cNvPr id="51" name="Text 43"/>
-          <p:cNvSpPr txBox="1"/>
-          <p:nvPr/>
-        </p:nvSpPr>
-        <p:spPr>
-          <a:xfrm>
-            <a:off x="4621682" y="3520440"/>
+          <p:cNvPr id="56" name="Text 47"/>
+          <p:cNvSpPr txBox="1"/>
+          <p:nvPr/>
+        </p:nvSpPr>
+        <p:spPr>
+          <a:xfrm>
+            <a:off x="4621682" y="3858768"/>
             <a:ext cx="621792" cy="173736"/>
           </a:xfrm>
           <a:prstGeom prst="rect">
@@ -6348,13 +6396,13 @@
       </p:sp>
       <p:sp>
         <p:nvSpPr>
-          <p:cNvPr id="52" name="Text 44"/>
-          <p:cNvSpPr txBox="1"/>
-          <p:nvPr/>
-        </p:nvSpPr>
-        <p:spPr>
-          <a:xfrm>
-            <a:off x="2414016" y="3730752"/>
+          <p:cNvPr id="57" name="Text 48"/>
+          <p:cNvSpPr txBox="1"/>
+          <p:nvPr/>
+        </p:nvSpPr>
+        <p:spPr>
+          <a:xfrm>
+            <a:off x="2414016" y="4069080"/>
             <a:ext cx="2792882" cy="512064"/>
           </a:xfrm>
           <a:prstGeom prst="rect">
@@ -6390,14 +6438,14 @@
       </p:sp>
       <p:sp>
         <p:nvSpPr>
-          <p:cNvPr id="53" name="Text 45"/>
-          <p:cNvSpPr txBox="1"/>
-          <p:nvPr/>
-        </p:nvSpPr>
-        <p:spPr>
-          <a:xfrm>
-            <a:off x="2414016" y="4279392"/>
-            <a:ext cx="2792882" cy="530352"/>
+          <p:cNvPr id="58" name="Text 49"/>
+          <p:cNvSpPr txBox="1"/>
+          <p:nvPr/>
+        </p:nvSpPr>
+        <p:spPr>
+          <a:xfrm>
+            <a:off x="2414016" y="4617720"/>
+            <a:ext cx="2792882" cy="347472"/>
           </a:xfrm>
           <a:prstGeom prst="rect">
             <a:avLst/>
@@ -6432,13 +6480,13 @@
       </p:sp>
       <p:sp>
         <p:nvSpPr>
-          <p:cNvPr id="54" name="Shape 46"/>
+          <p:cNvPr id="59" name="Shape 50"/>
           <p:cNvSpPr/>
           <p:nvPr/>
         </p:nvSpPr>
         <p:spPr>
           <a:xfrm>
-            <a:off x="2414016" y="4882896"/>
+            <a:off x="2414016" y="5038344"/>
             <a:ext cx="2792882" cy="0"/>
           </a:xfrm>
           <a:prstGeom prst="line">
@@ -6455,13 +6503,13 @@
       </p:sp>
       <p:sp>
         <p:nvSpPr>
-          <p:cNvPr id="55" name="Text 47"/>
-          <p:cNvSpPr txBox="1"/>
-          <p:nvPr/>
-        </p:nvSpPr>
-        <p:spPr>
-          <a:xfrm>
-            <a:off x="2414016" y="4928616"/>
+          <p:cNvPr id="60" name="Text 51"/>
+          <p:cNvSpPr txBox="1"/>
+          <p:nvPr/>
+        </p:nvSpPr>
+        <p:spPr>
+          <a:xfrm>
+            <a:off x="2414016" y="5084064"/>
             <a:ext cx="1829349" cy="182880"/>
           </a:xfrm>
           <a:prstGeom prst="rect">
@@ -6494,13 +6542,13 @@
       </p:sp>
       <p:sp>
         <p:nvSpPr>
-          <p:cNvPr id="56" name="Text 48"/>
-          <p:cNvSpPr txBox="1"/>
-          <p:nvPr/>
-        </p:nvSpPr>
-        <p:spPr>
-          <a:xfrm>
-            <a:off x="4557674" y="4928616"/>
+          <p:cNvPr id="61" name="Text 52"/>
+          <p:cNvSpPr txBox="1"/>
+          <p:nvPr/>
+        </p:nvSpPr>
+        <p:spPr>
+          <a:xfrm>
+            <a:off x="4557674" y="5084064"/>
             <a:ext cx="658368" cy="182880"/>
           </a:xfrm>
           <a:prstGeom prst="rect">
@@ -6533,18 +6581,18 @@
       </p:sp>
       <p:sp>
         <p:nvSpPr>
-          <p:cNvPr id="57" name="Shape 49"/>
+          <p:cNvPr id="62" name="Shape 53"/>
           <p:cNvSpPr/>
           <p:nvPr/>
         </p:nvSpPr>
         <p:spPr>
           <a:xfrm>
-            <a:off x="5554370" y="3438144"/>
-            <a:ext cx="3048914" cy="1737360"/>
+            <a:off x="5554370" y="3776472"/>
+            <a:ext cx="3048914" cy="1554480"/>
           </a:xfrm>
           <a:prstGeom prst="roundRect">
             <a:avLst>
-              <a:gd name="adj" fmla="val 2632"/>
+              <a:gd name="adj" fmla="val 2941"/>
             </a:avLst>
           </a:prstGeom>
           <a:solidFill>
@@ -6567,13 +6615,13 @@
       </p:sp>
       <p:sp>
         <p:nvSpPr>
-          <p:cNvPr id="58" name="Text 50"/>
-          <p:cNvSpPr txBox="1"/>
-          <p:nvPr/>
-        </p:nvSpPr>
-        <p:spPr>
-          <a:xfrm>
-            <a:off x="5682386" y="3529584"/>
+          <p:cNvPr id="63" name="Text 54"/>
+          <p:cNvSpPr txBox="1"/>
+          <p:nvPr/>
+        </p:nvSpPr>
+        <p:spPr>
+          <a:xfrm>
+            <a:off x="5682386" y="3867912"/>
             <a:ext cx="1676903" cy="182880"/>
           </a:xfrm>
           <a:prstGeom prst="rect">
@@ -6606,13 +6654,13 @@
       </p:sp>
       <p:sp>
         <p:nvSpPr>
-          <p:cNvPr id="59" name="Shape 51"/>
+          <p:cNvPr id="64" name="Shape 55"/>
           <p:cNvSpPr/>
           <p:nvPr/>
         </p:nvSpPr>
         <p:spPr>
           <a:xfrm>
-            <a:off x="7890053" y="3520440"/>
+            <a:off x="7890053" y="3858768"/>
             <a:ext cx="621792" cy="173736"/>
           </a:xfrm>
           <a:prstGeom prst="roundRect">
@@ -6633,13 +6681,13 @@
       </p:sp>
       <p:sp>
         <p:nvSpPr>
-          <p:cNvPr id="60" name="Text 52"/>
-          <p:cNvSpPr txBox="1"/>
-          <p:nvPr/>
-        </p:nvSpPr>
-        <p:spPr>
-          <a:xfrm>
-            <a:off x="7890053" y="3520440"/>
+          <p:cNvPr id="65" name="Text 56"/>
+          <p:cNvSpPr txBox="1"/>
+          <p:nvPr/>
+        </p:nvSpPr>
+        <p:spPr>
+          <a:xfrm>
+            <a:off x="7890053" y="3858768"/>
             <a:ext cx="621792" cy="173736"/>
           </a:xfrm>
           <a:prstGeom prst="rect">
@@ -6672,13 +6720,13 @@
       </p:sp>
       <p:sp>
         <p:nvSpPr>
-          <p:cNvPr id="61" name="Text 53"/>
-          <p:cNvSpPr txBox="1"/>
-          <p:nvPr/>
-        </p:nvSpPr>
-        <p:spPr>
-          <a:xfrm>
-            <a:off x="5682386" y="3730752"/>
+          <p:cNvPr id="66" name="Text 57"/>
+          <p:cNvSpPr txBox="1"/>
+          <p:nvPr/>
+        </p:nvSpPr>
+        <p:spPr>
+          <a:xfrm>
+            <a:off x="5682386" y="4069080"/>
             <a:ext cx="2792882" cy="512064"/>
           </a:xfrm>
           <a:prstGeom prst="rect">
@@ -6714,14 +6762,14 @@
       </p:sp>
       <p:sp>
         <p:nvSpPr>
-          <p:cNvPr id="62" name="Text 54"/>
-          <p:cNvSpPr txBox="1"/>
-          <p:nvPr/>
-        </p:nvSpPr>
-        <p:spPr>
-          <a:xfrm>
-            <a:off x="5682386" y="4279392"/>
-            <a:ext cx="2792882" cy="530352"/>
+          <p:cNvPr id="67" name="Text 58"/>
+          <p:cNvSpPr txBox="1"/>
+          <p:nvPr/>
+        </p:nvSpPr>
+        <p:spPr>
+          <a:xfrm>
+            <a:off x="5682386" y="4617720"/>
+            <a:ext cx="2792882" cy="347472"/>
           </a:xfrm>
           <a:prstGeom prst="rect">
             <a:avLst/>
@@ -6756,13 +6804,13 @@
       </p:sp>
       <p:sp>
         <p:nvSpPr>
-          <p:cNvPr id="63" name="Shape 55"/>
+          <p:cNvPr id="68" name="Shape 59"/>
           <p:cNvSpPr/>
           <p:nvPr/>
         </p:nvSpPr>
         <p:spPr>
           <a:xfrm>
-            <a:off x="5682386" y="4882896"/>
+            <a:off x="5682386" y="5038344"/>
             <a:ext cx="2792882" cy="0"/>
           </a:xfrm>
           <a:prstGeom prst="line">
@@ -6779,13 +6827,13 @@
       </p:sp>
       <p:sp>
         <p:nvSpPr>
-          <p:cNvPr id="64" name="Text 56"/>
-          <p:cNvSpPr txBox="1"/>
-          <p:nvPr/>
-        </p:nvSpPr>
-        <p:spPr>
-          <a:xfrm>
-            <a:off x="5682386" y="4928616"/>
+          <p:cNvPr id="69" name="Text 60"/>
+          <p:cNvSpPr txBox="1"/>
+          <p:nvPr/>
+        </p:nvSpPr>
+        <p:spPr>
+          <a:xfrm>
+            <a:off x="5682386" y="5084064"/>
             <a:ext cx="1829349" cy="182880"/>
           </a:xfrm>
           <a:prstGeom prst="rect">
@@ -6818,13 +6866,13 @@
       </p:sp>
       <p:sp>
         <p:nvSpPr>
-          <p:cNvPr id="65" name="Text 57"/>
-          <p:cNvSpPr txBox="1"/>
-          <p:nvPr/>
-        </p:nvSpPr>
-        <p:spPr>
-          <a:xfrm>
-            <a:off x="7826045" y="4928616"/>
+          <p:cNvPr id="70" name="Text 61"/>
+          <p:cNvSpPr txBox="1"/>
+          <p:nvPr/>
+        </p:nvSpPr>
+        <p:spPr>
+          <a:xfrm>
+            <a:off x="7826045" y="5084064"/>
             <a:ext cx="658368" cy="182880"/>
           </a:xfrm>
           <a:prstGeom prst="rect">
@@ -6857,18 +6905,18 @@
       </p:sp>
       <p:sp>
         <p:nvSpPr>
-          <p:cNvPr id="66" name="Shape 58"/>
+          <p:cNvPr id="71" name="Shape 62"/>
           <p:cNvSpPr/>
           <p:nvPr/>
         </p:nvSpPr>
         <p:spPr>
           <a:xfrm>
-            <a:off x="8822741" y="3438144"/>
-            <a:ext cx="3048914" cy="1737360"/>
+            <a:off x="8822741" y="3776472"/>
+            <a:ext cx="3048914" cy="1554480"/>
           </a:xfrm>
           <a:prstGeom prst="roundRect">
             <a:avLst>
-              <a:gd name="adj" fmla="val 2632"/>
+              <a:gd name="adj" fmla="val 2941"/>
             </a:avLst>
           </a:prstGeom>
           <a:solidFill>
@@ -6891,13 +6939,13 @@
       </p:sp>
       <p:sp>
         <p:nvSpPr>
-          <p:cNvPr id="67" name="Text 59"/>
-          <p:cNvSpPr txBox="1"/>
-          <p:nvPr/>
-        </p:nvSpPr>
-        <p:spPr>
-          <a:xfrm>
-            <a:off x="8950757" y="3529584"/>
+          <p:cNvPr id="72" name="Text 63"/>
+          <p:cNvSpPr txBox="1"/>
+          <p:nvPr/>
+        </p:nvSpPr>
+        <p:spPr>
+          <a:xfrm>
+            <a:off x="8950757" y="3867912"/>
             <a:ext cx="1676903" cy="182880"/>
           </a:xfrm>
           <a:prstGeom prst="rect">
@@ -6930,13 +6978,13 @@
       </p:sp>
       <p:sp>
         <p:nvSpPr>
-          <p:cNvPr id="68" name="Text 60"/>
-          <p:cNvSpPr txBox="1"/>
-          <p:nvPr/>
-        </p:nvSpPr>
-        <p:spPr>
-          <a:xfrm>
-            <a:off x="8950757" y="3730752"/>
+          <p:cNvPr id="73" name="Text 64"/>
+          <p:cNvSpPr txBox="1"/>
+          <p:nvPr/>
+        </p:nvSpPr>
+        <p:spPr>
+          <a:xfrm>
+            <a:off x="8950757" y="4069080"/>
             <a:ext cx="2792882" cy="512064"/>
           </a:xfrm>
           <a:prstGeom prst="rect">
@@ -6972,14 +7020,14 @@
       </p:sp>
       <p:sp>
         <p:nvSpPr>
-          <p:cNvPr id="69" name="Text 61"/>
-          <p:cNvSpPr txBox="1"/>
-          <p:nvPr/>
-        </p:nvSpPr>
-        <p:spPr>
-          <a:xfrm>
-            <a:off x="8950757" y="4279392"/>
-            <a:ext cx="2792882" cy="530352"/>
+          <p:cNvPr id="74" name="Text 65"/>
+          <p:cNvSpPr txBox="1"/>
+          <p:nvPr/>
+        </p:nvSpPr>
+        <p:spPr>
+          <a:xfrm>
+            <a:off x="8950757" y="4617720"/>
+            <a:ext cx="2792882" cy="347472"/>
           </a:xfrm>
           <a:prstGeom prst="rect">
             <a:avLst/>
@@ -7014,13 +7062,13 @@
       </p:sp>
       <p:sp>
         <p:nvSpPr>
-          <p:cNvPr id="70" name="Shape 62"/>
+          <p:cNvPr id="75" name="Shape 66"/>
           <p:cNvSpPr/>
           <p:nvPr/>
         </p:nvSpPr>
         <p:spPr>
           <a:xfrm>
-            <a:off x="8950757" y="4882896"/>
+            <a:off x="8950757" y="5038344"/>
             <a:ext cx="2792882" cy="0"/>
           </a:xfrm>
           <a:prstGeom prst="line">
@@ -7037,13 +7085,13 @@
       </p:sp>
       <p:sp>
         <p:nvSpPr>
-          <p:cNvPr id="71" name="Text 63"/>
-          <p:cNvSpPr txBox="1"/>
-          <p:nvPr/>
-        </p:nvSpPr>
-        <p:spPr>
-          <a:xfrm>
-            <a:off x="8950757" y="4928616"/>
+          <p:cNvPr id="76" name="Text 67"/>
+          <p:cNvSpPr txBox="1"/>
+          <p:nvPr/>
+        </p:nvSpPr>
+        <p:spPr>
+          <a:xfrm>
+            <a:off x="8950757" y="5084064"/>
             <a:ext cx="1829349" cy="182880"/>
           </a:xfrm>
           <a:prstGeom prst="rect">
@@ -7076,13 +7124,13 @@
       </p:sp>
       <p:sp>
         <p:nvSpPr>
-          <p:cNvPr id="72" name="Text 64"/>
-          <p:cNvSpPr txBox="1"/>
-          <p:nvPr/>
-        </p:nvSpPr>
-        <p:spPr>
-          <a:xfrm>
-            <a:off x="11094415" y="4928616"/>
+          <p:cNvPr id="77" name="Text 68"/>
+          <p:cNvSpPr txBox="1"/>
+          <p:nvPr/>
+        </p:nvSpPr>
+        <p:spPr>
+          <a:xfrm>
+            <a:off x="11094415" y="5084064"/>
             <a:ext cx="658368" cy="182880"/>
           </a:xfrm>
           <a:prstGeom prst="rect">
@@ -7115,13 +7163,33 @@
       </p:sp>
       <p:sp>
         <p:nvSpPr>
-          <p:cNvPr id="73" name="Text 65"/>
-          <p:cNvSpPr txBox="1"/>
-          <p:nvPr/>
-        </p:nvSpPr>
-        <p:spPr>
-          <a:xfrm>
-            <a:off x="2286000" y="5376672"/>
+          <p:cNvPr id="78" name="Shape 69"/>
+          <p:cNvSpPr/>
+          <p:nvPr/>
+        </p:nvSpPr>
+        <p:spPr>
+          <a:xfrm>
+            <a:off x="2286000" y="5550408"/>
+            <a:ext cx="109728" cy="109728"/>
+          </a:xfrm>
+          <a:prstGeom prst="rect">
+            <a:avLst/>
+          </a:prstGeom>
+          <a:solidFill>
+            <a:srgbClr val="C1432A"/>
+          </a:solidFill>
+          <a:ln/>
+        </p:spPr>
+      </p:sp>
+      <p:sp>
+        <p:nvSpPr>
+          <p:cNvPr id="79" name="Text 70"/>
+          <p:cNvSpPr txBox="1"/>
+          <p:nvPr/>
+        </p:nvSpPr>
+        <p:spPr>
+          <a:xfrm>
+            <a:off x="2468880" y="5532120"/>
             <a:ext cx="4572000" cy="219456"/>
           </a:xfrm>
           <a:prstGeom prst="rect">
@@ -7140,7 +7208,7 @@
             <a:r>
               <a:rPr lang="en-US" sz="900" spc="100" kern="0" dirty="0">
                 <a:solidFill>
-                  <a:srgbClr val="4B4B4B"/>
+                  <a:srgbClr val="022049"/>
                 </a:solidFill>
                 <a:latin typeface="Courier New" pitchFamily="34" charset="0"/>
                 <a:ea typeface="Courier New" pitchFamily="34" charset="-122"/>
@@ -7154,13 +7222,13 @@
       </p:sp>
       <p:sp>
         <p:nvSpPr>
-          <p:cNvPr id="74" name="Shape 66"/>
+          <p:cNvPr id="80" name="Shape 71"/>
           <p:cNvSpPr/>
           <p:nvPr/>
         </p:nvSpPr>
         <p:spPr>
           <a:xfrm>
-            <a:off x="2286000" y="5632704"/>
+            <a:off x="2286000" y="5788152"/>
             <a:ext cx="9585655" cy="658368"/>
           </a:xfrm>
           <a:prstGeom prst="roundRect">
@@ -7169,7 +7237,7 @@
             </a:avLst>
           </a:prstGeom>
           <a:solidFill>
-            <a:srgbClr val="FBFCFC"/>
+            <a:srgbClr val="E4EAF3"/>
           </a:solidFill>
           <a:ln w="12700">
             <a:solidFill>
@@ -7181,14 +7249,14 @@
       </p:sp>
       <p:sp>
         <p:nvSpPr>
-          <p:cNvPr id="75" name="Shape 67"/>
+          <p:cNvPr id="81" name="Shape 72"/>
           <p:cNvSpPr/>
           <p:nvPr/>
         </p:nvSpPr>
         <p:spPr>
           <a:xfrm>
-            <a:off x="2286000" y="5632704"/>
-            <a:ext cx="45720" cy="658368"/>
+            <a:off x="2286000" y="5788152"/>
+            <a:ext cx="54864" cy="658368"/>
           </a:xfrm>
           <a:prstGeom prst="rect">
             <a:avLst/>
@@ -7201,13 +7269,13 @@
       </p:sp>
       <p:sp>
         <p:nvSpPr>
-          <p:cNvPr id="76" name="Text 68"/>
-          <p:cNvSpPr txBox="1"/>
-          <p:nvPr/>
-        </p:nvSpPr>
-        <p:spPr>
-          <a:xfrm>
-            <a:off x="2514600" y="5705856"/>
+          <p:cNvPr id="82" name="Text 73"/>
+          <p:cNvSpPr txBox="1"/>
+          <p:nvPr/>
+        </p:nvSpPr>
+        <p:spPr>
+          <a:xfrm>
+            <a:off x="2514600" y="5861304"/>
             <a:ext cx="5486400" cy="237744"/>
           </a:xfrm>
           <a:prstGeom prst="rect">
@@ -7240,13 +7308,13 @@
       </p:sp>
       <p:sp>
         <p:nvSpPr>
-          <p:cNvPr id="77" name="Text 69"/>
-          <p:cNvSpPr txBox="1"/>
-          <p:nvPr/>
-        </p:nvSpPr>
-        <p:spPr>
-          <a:xfrm>
-            <a:off x="2514600" y="5961888"/>
+          <p:cNvPr id="83" name="Text 74"/>
+          <p:cNvSpPr txBox="1"/>
+          <p:nvPr/>
+        </p:nvSpPr>
+        <p:spPr>
+          <a:xfrm>
+            <a:off x="2514600" y="6117336"/>
             <a:ext cx="7315200" cy="310896"/>
           </a:xfrm>
           <a:prstGeom prst="rect">
@@ -7279,13 +7347,13 @@
       </p:sp>
       <p:sp>
         <p:nvSpPr>
-          <p:cNvPr id="78" name="Text 70"/>
-          <p:cNvSpPr txBox="1"/>
-          <p:nvPr/>
-        </p:nvSpPr>
-        <p:spPr>
-          <a:xfrm>
-            <a:off x="10728655" y="5705856"/>
+          <p:cNvPr id="84" name="Text 75"/>
+          <p:cNvSpPr txBox="1"/>
+          <p:nvPr/>
+        </p:nvSpPr>
+        <p:spPr>
+          <a:xfrm>
+            <a:off x="10728655" y="5861304"/>
             <a:ext cx="1005840" cy="219456"/>
           </a:xfrm>
           <a:prstGeom prst="rect">

</xml_diff>

<commit_message>
Replace flat navy hero band with a diagonal gradient + glow
The Home page's tile band now uses a baked-in rounded-corner gradient image
(navy to deep charcoal-navy, soft glow upper-left) instead of a flat navy
shape fill, echoing the title slide's background treatment.

Co-Authored-By: Claude Sonnet 5 <noreply@anthropic.com>
Claude-Session: https://claude.ai/code/session_01YAQcUYpy57Up3cir28mVUA
</commit_message>
<xml_diff>
--- a/office-hub-concept.pptx
+++ b/office-hub-concept.pptx
@@ -5586,26 +5586,28 @@
           </a:ln>
         </p:spPr>
       </p:sp>
-      <p:sp>
-        <p:nvSpPr>
-          <p:cNvPr id="29" name="Shape 27"/>
-          <p:cNvSpPr/>
-          <p:nvPr/>
-        </p:nvSpPr>
+      <p:pic>
+        <p:nvPicPr>
+          <p:cNvPr id="29" name="Image 0" descr="/tmp/claude-0/-home-user-drawing-set/4abccc73-5df9-5ad5-9792-19a3f012db48/scratchpad/tile_band.png">    </p:cNvPr>
+          <p:cNvPicPr>
+            <a:picLocks noChangeAspect="1"/>
+          </p:cNvPicPr>
+          <p:nvPr/>
+        </p:nvPicPr>
+        <p:blipFill>
+          <a:blip r:embed="rId2"/>
+          <a:stretch>
+            <a:fillRect/>
+          </a:stretch>
+        </p:blipFill>
         <p:spPr>
           <a:xfrm>
             <a:off x="2139696" y="1920240"/>
             <a:ext cx="9878263" cy="1344168"/>
           </a:xfrm>
-          <a:prstGeom prst="roundRect">
-            <a:avLst>
-              <a:gd name="adj" fmla="val 5442"/>
-            </a:avLst>
-          </a:prstGeom>
-          <a:solidFill>
-            <a:srgbClr val="022049"/>
-          </a:solidFill>
-          <a:ln/>
+          <a:prstGeom prst="rect">
+            <a:avLst/>
+          </a:prstGeom>
           <a:effectLst>
             <a:outerShdw sx="100000" sy="100000" kx="0" ky="0" algn="bl" rotWithShape="0" blurRad="101600" dist="38100" dir="5400000">
               <a:srgbClr val="000000">
@@ -5614,10 +5616,10 @@
             </a:outerShdw>
           </a:effectLst>
         </p:spPr>
-      </p:sp>
-      <p:sp>
-        <p:nvSpPr>
-          <p:cNvPr id="30" name="Shape 28"/>
+      </p:pic>
+      <p:sp>
+        <p:nvSpPr>
+          <p:cNvPr id="30" name="Shape 27"/>
           <p:cNvSpPr/>
           <p:nvPr/>
         </p:nvSpPr>
@@ -5637,90 +5639,7 @@
       </p:sp>
       <p:pic>
         <p:nvPicPr>
-          <p:cNvPr id="31" name="Image 0" descr="/tmp/claude-0/-home-user-drawing-set/4abccc73-5df9-5ad5-9792-19a3f012db48/scratchpad/icons/standards.png">    </p:cNvPr>
-          <p:cNvPicPr>
-            <a:picLocks noChangeAspect="1"/>
-          </p:cNvPicPr>
-          <p:nvPr/>
-        </p:nvPicPr>
-        <p:blipFill>
-          <a:blip r:embed="rId2"/>
-          <a:stretch>
-            <a:fillRect/>
-          </a:stretch>
-        </p:blipFill>
-        <p:spPr>
-          <a:xfrm>
-            <a:off x="2769522" y="2267712"/>
-            <a:ext cx="292608" cy="292608"/>
-          </a:xfrm>
-          <a:prstGeom prst="rect">
-            <a:avLst/>
-          </a:prstGeom>
-        </p:spPr>
-      </p:pic>
-      <p:sp>
-        <p:nvSpPr>
-          <p:cNvPr id="32" name="Text 29"/>
-          <p:cNvSpPr txBox="1"/>
-          <p:nvPr/>
-        </p:nvSpPr>
-        <p:spPr>
-          <a:xfrm>
-            <a:off x="2286000" y="2724912"/>
-            <a:ext cx="1259651" cy="329184"/>
-          </a:xfrm>
-          <a:prstGeom prst="rect">
-            <a:avLst/>
-          </a:prstGeom>
-          <a:noFill/>
-          <a:ln/>
-        </p:spPr>
-        <p:txBody>
-          <a:bodyPr wrap="square" lIns="0" tIns="0" rIns="0" bIns="0" rtlCol="0" anchor="t"/>
-          <a:lstStyle/>
-          <a:p>
-            <a:pPr algn="ctr" indent="0" marL="0">
-              <a:buNone/>
-            </a:pPr>
-            <a:r>
-              <a:rPr lang="en-US" sz="900" b="1" dirty="0">
-                <a:solidFill>
-                  <a:srgbClr val="FFFFFF"/>
-                </a:solidFill>
-                <a:latin typeface="Arial" pitchFamily="34" charset="0"/>
-                <a:ea typeface="Arial" pitchFamily="34" charset="-122"/>
-                <a:cs typeface="Arial" pitchFamily="34" charset="-120"/>
-              </a:rPr>
-              <a:t>STANDARDS</a:t>
-            </a:r>
-            <a:endParaRPr lang="en-US" sz="900" dirty="0"/>
-          </a:p>
-        </p:txBody>
-      </p:sp>
-      <p:sp>
-        <p:nvSpPr>
-          <p:cNvPr id="33" name="Shape 30"/>
-          <p:cNvSpPr/>
-          <p:nvPr/>
-        </p:nvSpPr>
-        <p:spPr>
-          <a:xfrm>
-            <a:off x="4065749" y="2176272"/>
-            <a:ext cx="475488" cy="475488"/>
-          </a:xfrm>
-          <a:prstGeom prst="ellipse">
-            <a:avLst/>
-          </a:prstGeom>
-          <a:solidFill>
-            <a:srgbClr val="FFFFFF"/>
-          </a:solidFill>
-          <a:ln/>
-        </p:spPr>
-      </p:sp>
-      <p:pic>
-        <p:nvPicPr>
-          <p:cNvPr id="34" name="Image 1" descr="/tmp/claude-0/-home-user-drawing-set/4abccc73-5df9-5ad5-9792-19a3f012db48/scratchpad/icons/templates.png">    </p:cNvPr>
+          <p:cNvPr id="31" name="Image 1" descr="/tmp/claude-0/-home-user-drawing-set/4abccc73-5df9-5ad5-9792-19a3f012db48/scratchpad/icons/standards.png">    </p:cNvPr>
           <p:cNvPicPr>
             <a:picLocks noChangeAspect="1"/>
           </p:cNvPicPr>
@@ -5734,7 +5653,7 @@
         </p:blipFill>
         <p:spPr>
           <a:xfrm>
-            <a:off x="4157189" y="2267712"/>
+            <a:off x="2769522" y="2267712"/>
             <a:ext cx="292608" cy="292608"/>
           </a:xfrm>
           <a:prstGeom prst="rect">
@@ -5744,13 +5663,13 @@
       </p:pic>
       <p:sp>
         <p:nvSpPr>
-          <p:cNvPr id="35" name="Text 31"/>
-          <p:cNvSpPr txBox="1"/>
-          <p:nvPr/>
-        </p:nvSpPr>
-        <p:spPr>
-          <a:xfrm>
-            <a:off x="3673667" y="2724912"/>
+          <p:cNvPr id="32" name="Text 28"/>
+          <p:cNvSpPr txBox="1"/>
+          <p:nvPr/>
+        </p:nvSpPr>
+        <p:spPr>
+          <a:xfrm>
+            <a:off x="2286000" y="2724912"/>
             <a:ext cx="1259651" cy="329184"/>
           </a:xfrm>
           <a:prstGeom prst="rect">
@@ -5775,7 +5694,7 @@
                 <a:ea typeface="Arial" pitchFamily="34" charset="-122"/>
                 <a:cs typeface="Arial" pitchFamily="34" charset="-120"/>
               </a:rPr>
-              <a:t>TEMPLATES</a:t>
+              <a:t>STANDARDS</a:t>
             </a:r>
             <a:endParaRPr lang="en-US" sz="900" dirty="0"/>
           </a:p>
@@ -5783,13 +5702,13 @@
       </p:sp>
       <p:sp>
         <p:nvSpPr>
-          <p:cNvPr id="36" name="Shape 32"/>
+          <p:cNvPr id="33" name="Shape 29"/>
           <p:cNvSpPr/>
           <p:nvPr/>
         </p:nvSpPr>
         <p:spPr>
           <a:xfrm>
-            <a:off x="5453416" y="2176272"/>
+            <a:off x="4065749" y="2176272"/>
             <a:ext cx="475488" cy="475488"/>
           </a:xfrm>
           <a:prstGeom prst="ellipse">
@@ -5803,7 +5722,7 @@
       </p:sp>
       <p:pic>
         <p:nvPicPr>
-          <p:cNvPr id="37" name="Image 2" descr="/tmp/claude-0/-home-user-drawing-set/4abccc73-5df9-5ad5-9792-19a3f012db48/scratchpad/icons/forms.png">    </p:cNvPr>
+          <p:cNvPr id="34" name="Image 2" descr="/tmp/claude-0/-home-user-drawing-set/4abccc73-5df9-5ad5-9792-19a3f012db48/scratchpad/icons/templates.png">    </p:cNvPr>
           <p:cNvPicPr>
             <a:picLocks noChangeAspect="1"/>
           </p:cNvPicPr>
@@ -5817,7 +5736,7 @@
         </p:blipFill>
         <p:spPr>
           <a:xfrm>
-            <a:off x="5544856" y="2267712"/>
+            <a:off x="4157189" y="2267712"/>
             <a:ext cx="292608" cy="292608"/>
           </a:xfrm>
           <a:prstGeom prst="rect">
@@ -5827,13 +5746,13 @@
       </p:pic>
       <p:sp>
         <p:nvSpPr>
-          <p:cNvPr id="38" name="Text 33"/>
-          <p:cNvSpPr txBox="1"/>
-          <p:nvPr/>
-        </p:nvSpPr>
-        <p:spPr>
-          <a:xfrm>
-            <a:off x="5061335" y="2724912"/>
+          <p:cNvPr id="35" name="Text 30"/>
+          <p:cNvSpPr txBox="1"/>
+          <p:nvPr/>
+        </p:nvSpPr>
+        <p:spPr>
+          <a:xfrm>
+            <a:off x="3673667" y="2724912"/>
             <a:ext cx="1259651" cy="329184"/>
           </a:xfrm>
           <a:prstGeom prst="rect">
@@ -5858,7 +5777,7 @@
                 <a:ea typeface="Arial" pitchFamily="34" charset="-122"/>
                 <a:cs typeface="Arial" pitchFamily="34" charset="-120"/>
               </a:rPr>
-              <a:t>FORMS</a:t>
+              <a:t>TEMPLATES</a:t>
             </a:r>
             <a:endParaRPr lang="en-US" sz="900" dirty="0"/>
           </a:p>
@@ -5866,13 +5785,13 @@
       </p:sp>
       <p:sp>
         <p:nvSpPr>
-          <p:cNvPr id="39" name="Shape 34"/>
+          <p:cNvPr id="36" name="Shape 31"/>
           <p:cNvSpPr/>
           <p:nvPr/>
         </p:nvSpPr>
         <p:spPr>
           <a:xfrm>
-            <a:off x="6841084" y="2176272"/>
+            <a:off x="5453416" y="2176272"/>
             <a:ext cx="475488" cy="475488"/>
           </a:xfrm>
           <a:prstGeom prst="ellipse">
@@ -5886,7 +5805,7 @@
       </p:sp>
       <p:pic>
         <p:nvPicPr>
-          <p:cNvPr id="40" name="Image 3" descr="/tmp/claude-0/-home-user-drawing-set/4abccc73-5df9-5ad5-9792-19a3f012db48/scratchpad/icons/policies.png">    </p:cNvPr>
+          <p:cNvPr id="37" name="Image 3" descr="/tmp/claude-0/-home-user-drawing-set/4abccc73-5df9-5ad5-9792-19a3f012db48/scratchpad/icons/forms.png">    </p:cNvPr>
           <p:cNvPicPr>
             <a:picLocks noChangeAspect="1"/>
           </p:cNvPicPr>
@@ -5900,7 +5819,7 @@
         </p:blipFill>
         <p:spPr>
           <a:xfrm>
-            <a:off x="6932524" y="2267712"/>
+            <a:off x="5544856" y="2267712"/>
             <a:ext cx="292608" cy="292608"/>
           </a:xfrm>
           <a:prstGeom prst="rect">
@@ -5910,13 +5829,13 @@
       </p:pic>
       <p:sp>
         <p:nvSpPr>
-          <p:cNvPr id="41" name="Text 35"/>
-          <p:cNvSpPr txBox="1"/>
-          <p:nvPr/>
-        </p:nvSpPr>
-        <p:spPr>
-          <a:xfrm>
-            <a:off x="6449002" y="2724912"/>
+          <p:cNvPr id="38" name="Text 32"/>
+          <p:cNvSpPr txBox="1"/>
+          <p:nvPr/>
+        </p:nvSpPr>
+        <p:spPr>
+          <a:xfrm>
+            <a:off x="5061335" y="2724912"/>
             <a:ext cx="1259651" cy="329184"/>
           </a:xfrm>
           <a:prstGeom prst="rect">
@@ -5941,7 +5860,7 @@
                 <a:ea typeface="Arial" pitchFamily="34" charset="-122"/>
                 <a:cs typeface="Arial" pitchFamily="34" charset="-120"/>
               </a:rPr>
-              <a:t>POLICIES</a:t>
+              <a:t>FORMS</a:t>
             </a:r>
             <a:endParaRPr lang="en-US" sz="900" dirty="0"/>
           </a:p>
@@ -5949,13 +5868,13 @@
       </p:sp>
       <p:sp>
         <p:nvSpPr>
-          <p:cNvPr id="42" name="Shape 36"/>
+          <p:cNvPr id="39" name="Shape 33"/>
           <p:cNvSpPr/>
           <p:nvPr/>
         </p:nvSpPr>
         <p:spPr>
           <a:xfrm>
-            <a:off x="8228751" y="2176272"/>
+            <a:off x="6841084" y="2176272"/>
             <a:ext cx="475488" cy="475488"/>
           </a:xfrm>
           <a:prstGeom prst="ellipse">
@@ -5969,7 +5888,7 @@
       </p:sp>
       <p:pic>
         <p:nvPicPr>
-          <p:cNvPr id="43" name="Image 4" descr="/tmp/claude-0/-home-user-drawing-set/4abccc73-5df9-5ad5-9792-19a3f012db48/scratchpad/icons/sops.png">    </p:cNvPr>
+          <p:cNvPr id="40" name="Image 4" descr="/tmp/claude-0/-home-user-drawing-set/4abccc73-5df9-5ad5-9792-19a3f012db48/scratchpad/icons/policies.png">    </p:cNvPr>
           <p:cNvPicPr>
             <a:picLocks noChangeAspect="1"/>
           </p:cNvPicPr>
@@ -5983,7 +5902,7 @@
         </p:blipFill>
         <p:spPr>
           <a:xfrm>
-            <a:off x="8320191" y="2267712"/>
+            <a:off x="6932524" y="2267712"/>
             <a:ext cx="292608" cy="292608"/>
           </a:xfrm>
           <a:prstGeom prst="rect">
@@ -5993,13 +5912,13 @@
       </p:pic>
       <p:sp>
         <p:nvSpPr>
-          <p:cNvPr id="44" name="Text 37"/>
-          <p:cNvSpPr txBox="1"/>
-          <p:nvPr/>
-        </p:nvSpPr>
-        <p:spPr>
-          <a:xfrm>
-            <a:off x="7836669" y="2724912"/>
+          <p:cNvPr id="41" name="Text 34"/>
+          <p:cNvSpPr txBox="1"/>
+          <p:nvPr/>
+        </p:nvSpPr>
+        <p:spPr>
+          <a:xfrm>
+            <a:off x="6449002" y="2724912"/>
             <a:ext cx="1259651" cy="329184"/>
           </a:xfrm>
           <a:prstGeom prst="rect">
@@ -6024,7 +5943,7 @@
                 <a:ea typeface="Arial" pitchFamily="34" charset="-122"/>
                 <a:cs typeface="Arial" pitchFamily="34" charset="-120"/>
               </a:rPr>
-              <a:t>SOPS</a:t>
+              <a:t>POLICIES</a:t>
             </a:r>
             <a:endParaRPr lang="en-US" sz="900" dirty="0"/>
           </a:p>
@@ -6032,13 +5951,13 @@
       </p:sp>
       <p:sp>
         <p:nvSpPr>
-          <p:cNvPr id="45" name="Shape 38"/>
+          <p:cNvPr id="42" name="Shape 35"/>
           <p:cNvSpPr/>
           <p:nvPr/>
         </p:nvSpPr>
         <p:spPr>
           <a:xfrm>
-            <a:off x="9616418" y="2176272"/>
+            <a:off x="8228751" y="2176272"/>
             <a:ext cx="475488" cy="475488"/>
           </a:xfrm>
           <a:prstGeom prst="ellipse">
@@ -6052,7 +5971,7 @@
       </p:sp>
       <p:pic>
         <p:nvPicPr>
-          <p:cNvPr id="46" name="Image 5" descr="/tmp/claude-0/-home-user-drawing-set/4abccc73-5df9-5ad5-9792-19a3f012db48/scratchpad/icons/revit.png">    </p:cNvPr>
+          <p:cNvPr id="43" name="Image 5" descr="/tmp/claude-0/-home-user-drawing-set/4abccc73-5df9-5ad5-9792-19a3f012db48/scratchpad/icons/sops.png">    </p:cNvPr>
           <p:cNvPicPr>
             <a:picLocks noChangeAspect="1"/>
           </p:cNvPicPr>
@@ -6066,7 +5985,7 @@
         </p:blipFill>
         <p:spPr>
           <a:xfrm>
-            <a:off x="9707858" y="2267712"/>
+            <a:off x="8320191" y="2267712"/>
             <a:ext cx="292608" cy="292608"/>
           </a:xfrm>
           <a:prstGeom prst="rect">
@@ -6076,13 +5995,13 @@
       </p:pic>
       <p:sp>
         <p:nvSpPr>
-          <p:cNvPr id="47" name="Text 39"/>
-          <p:cNvSpPr txBox="1"/>
-          <p:nvPr/>
-        </p:nvSpPr>
-        <p:spPr>
-          <a:xfrm>
-            <a:off x="9224337" y="2724912"/>
+          <p:cNvPr id="44" name="Text 36"/>
+          <p:cNvSpPr txBox="1"/>
+          <p:nvPr/>
+        </p:nvSpPr>
+        <p:spPr>
+          <a:xfrm>
+            <a:off x="7836669" y="2724912"/>
             <a:ext cx="1259651" cy="329184"/>
           </a:xfrm>
           <a:prstGeom prst="rect">
@@ -6107,7 +6026,7 @@
                 <a:ea typeface="Arial" pitchFamily="34" charset="-122"/>
                 <a:cs typeface="Arial" pitchFamily="34" charset="-120"/>
               </a:rPr>
-              <a:t>REVIT STD.</a:t>
+              <a:t>SOPS</a:t>
             </a:r>
             <a:endParaRPr lang="en-US" sz="900" dirty="0"/>
           </a:p>
@@ -6115,13 +6034,13 @@
       </p:sp>
       <p:sp>
         <p:nvSpPr>
-          <p:cNvPr id="48" name="Shape 40"/>
+          <p:cNvPr id="45" name="Shape 37"/>
           <p:cNvSpPr/>
           <p:nvPr/>
         </p:nvSpPr>
         <p:spPr>
           <a:xfrm>
-            <a:off x="11004086" y="2176272"/>
+            <a:off x="9616418" y="2176272"/>
             <a:ext cx="475488" cy="475488"/>
           </a:xfrm>
           <a:prstGeom prst="ellipse">
@@ -6135,7 +6054,7 @@
       </p:sp>
       <p:pic>
         <p:nvPicPr>
-          <p:cNvPr id="49" name="Image 6" descr="/tmp/claude-0/-home-user-drawing-set/4abccc73-5df9-5ad5-9792-19a3f012db48/scratchpad/icons/learning.png">    </p:cNvPr>
+          <p:cNvPr id="46" name="Image 6" descr="/tmp/claude-0/-home-user-drawing-set/4abccc73-5df9-5ad5-9792-19a3f012db48/scratchpad/icons/revit.png">    </p:cNvPr>
           <p:cNvPicPr>
             <a:picLocks noChangeAspect="1"/>
           </p:cNvPicPr>
@@ -6149,7 +6068,7 @@
         </p:blipFill>
         <p:spPr>
           <a:xfrm>
-            <a:off x="11095526" y="2267712"/>
+            <a:off x="9707858" y="2267712"/>
             <a:ext cx="292608" cy="292608"/>
           </a:xfrm>
           <a:prstGeom prst="rect">
@@ -6159,13 +6078,13 @@
       </p:pic>
       <p:sp>
         <p:nvSpPr>
-          <p:cNvPr id="50" name="Text 41"/>
-          <p:cNvSpPr txBox="1"/>
-          <p:nvPr/>
-        </p:nvSpPr>
-        <p:spPr>
-          <a:xfrm>
-            <a:off x="10612004" y="2724912"/>
+          <p:cNvPr id="47" name="Text 38"/>
+          <p:cNvSpPr txBox="1"/>
+          <p:nvPr/>
+        </p:nvSpPr>
+        <p:spPr>
+          <a:xfrm>
+            <a:off x="9224337" y="2724912"/>
             <a:ext cx="1259651" cy="329184"/>
           </a:xfrm>
           <a:prstGeom prst="rect">
@@ -6190,6 +6109,89 @@
                 <a:ea typeface="Arial" pitchFamily="34" charset="-122"/>
                 <a:cs typeface="Arial" pitchFamily="34" charset="-120"/>
               </a:rPr>
+              <a:t>REVIT STD.</a:t>
+            </a:r>
+            <a:endParaRPr lang="en-US" sz="900" dirty="0"/>
+          </a:p>
+        </p:txBody>
+      </p:sp>
+      <p:sp>
+        <p:nvSpPr>
+          <p:cNvPr id="48" name="Shape 39"/>
+          <p:cNvSpPr/>
+          <p:nvPr/>
+        </p:nvSpPr>
+        <p:spPr>
+          <a:xfrm>
+            <a:off x="11004086" y="2176272"/>
+            <a:ext cx="475488" cy="475488"/>
+          </a:xfrm>
+          <a:prstGeom prst="ellipse">
+            <a:avLst/>
+          </a:prstGeom>
+          <a:solidFill>
+            <a:srgbClr val="FFFFFF"/>
+          </a:solidFill>
+          <a:ln/>
+        </p:spPr>
+      </p:sp>
+      <p:pic>
+        <p:nvPicPr>
+          <p:cNvPr id="49" name="Image 7" descr="/tmp/claude-0/-home-user-drawing-set/4abccc73-5df9-5ad5-9792-19a3f012db48/scratchpad/icons/learning.png">    </p:cNvPr>
+          <p:cNvPicPr>
+            <a:picLocks noChangeAspect="1"/>
+          </p:cNvPicPr>
+          <p:nvPr/>
+        </p:nvPicPr>
+        <p:blipFill>
+          <a:blip r:embed="rId9"/>
+          <a:stretch>
+            <a:fillRect/>
+          </a:stretch>
+        </p:blipFill>
+        <p:spPr>
+          <a:xfrm>
+            <a:off x="11095526" y="2267712"/>
+            <a:ext cx="292608" cy="292608"/>
+          </a:xfrm>
+          <a:prstGeom prst="rect">
+            <a:avLst/>
+          </a:prstGeom>
+        </p:spPr>
+      </p:pic>
+      <p:sp>
+        <p:nvSpPr>
+          <p:cNvPr id="50" name="Text 40"/>
+          <p:cNvSpPr txBox="1"/>
+          <p:nvPr/>
+        </p:nvSpPr>
+        <p:spPr>
+          <a:xfrm>
+            <a:off x="10612004" y="2724912"/>
+            <a:ext cx="1259651" cy="329184"/>
+          </a:xfrm>
+          <a:prstGeom prst="rect">
+            <a:avLst/>
+          </a:prstGeom>
+          <a:noFill/>
+          <a:ln/>
+        </p:spPr>
+        <p:txBody>
+          <a:bodyPr wrap="square" lIns="0" tIns="0" rIns="0" bIns="0" rtlCol="0" anchor="t"/>
+          <a:lstStyle/>
+          <a:p>
+            <a:pPr algn="ctr" indent="0" marL="0">
+              <a:buNone/>
+            </a:pPr>
+            <a:r>
+              <a:rPr lang="en-US" sz="900" b="1" dirty="0">
+                <a:solidFill>
+                  <a:srgbClr val="FFFFFF"/>
+                </a:solidFill>
+                <a:latin typeface="Arial" pitchFamily="34" charset="0"/>
+                <a:ea typeface="Arial" pitchFamily="34" charset="-122"/>
+                <a:cs typeface="Arial" pitchFamily="34" charset="-120"/>
+              </a:rPr>
               <a:t>LEARNING</a:t>
             </a:r>
             <a:endParaRPr lang="en-US" sz="900" dirty="0"/>
@@ -6198,7 +6200,7 @@
       </p:sp>
       <p:sp>
         <p:nvSpPr>
-          <p:cNvPr id="51" name="Shape 42"/>
+          <p:cNvPr id="51" name="Shape 41"/>
           <p:cNvSpPr/>
           <p:nvPr/>
         </p:nvSpPr>
@@ -6218,7 +6220,7 @@
       </p:sp>
       <p:sp>
         <p:nvSpPr>
-          <p:cNvPr id="52" name="Text 43"/>
+          <p:cNvPr id="52" name="Text 42"/>
           <p:cNvSpPr txBox="1"/>
           <p:nvPr/>
         </p:nvSpPr>
@@ -6257,7 +6259,7 @@
       </p:sp>
       <p:sp>
         <p:nvSpPr>
-          <p:cNvPr id="53" name="Shape 44"/>
+          <p:cNvPr id="53" name="Shape 43"/>
           <p:cNvSpPr/>
           <p:nvPr/>
         </p:nvSpPr>
@@ -6291,7 +6293,7 @@
       </p:sp>
       <p:sp>
         <p:nvSpPr>
-          <p:cNvPr id="54" name="Text 45"/>
+          <p:cNvPr id="54" name="Text 44"/>
           <p:cNvSpPr txBox="1"/>
           <p:nvPr/>
         </p:nvSpPr>
@@ -6330,7 +6332,7 @@
       </p:sp>
       <p:sp>
         <p:nvSpPr>
-          <p:cNvPr id="55" name="Shape 46"/>
+          <p:cNvPr id="55" name="Shape 45"/>
           <p:cNvSpPr/>
           <p:nvPr/>
         </p:nvSpPr>
@@ -6357,7 +6359,7 @@
       </p:sp>
       <p:sp>
         <p:nvSpPr>
-          <p:cNvPr id="56" name="Text 47"/>
+          <p:cNvPr id="56" name="Text 46"/>
           <p:cNvSpPr txBox="1"/>
           <p:nvPr/>
         </p:nvSpPr>
@@ -6396,7 +6398,7 @@
       </p:sp>
       <p:sp>
         <p:nvSpPr>
-          <p:cNvPr id="57" name="Text 48"/>
+          <p:cNvPr id="57" name="Text 47"/>
           <p:cNvSpPr txBox="1"/>
           <p:nvPr/>
         </p:nvSpPr>
@@ -6438,7 +6440,7 @@
       </p:sp>
       <p:sp>
         <p:nvSpPr>
-          <p:cNvPr id="58" name="Text 49"/>
+          <p:cNvPr id="58" name="Text 48"/>
           <p:cNvSpPr txBox="1"/>
           <p:nvPr/>
         </p:nvSpPr>
@@ -6480,7 +6482,7 @@
       </p:sp>
       <p:sp>
         <p:nvSpPr>
-          <p:cNvPr id="59" name="Shape 50"/>
+          <p:cNvPr id="59" name="Shape 49"/>
           <p:cNvSpPr/>
           <p:nvPr/>
         </p:nvSpPr>
@@ -6503,7 +6505,7 @@
       </p:sp>
       <p:sp>
         <p:nvSpPr>
-          <p:cNvPr id="60" name="Text 51"/>
+          <p:cNvPr id="60" name="Text 50"/>
           <p:cNvSpPr txBox="1"/>
           <p:nvPr/>
         </p:nvSpPr>
@@ -6542,7 +6544,7 @@
       </p:sp>
       <p:sp>
         <p:nvSpPr>
-          <p:cNvPr id="61" name="Text 52"/>
+          <p:cNvPr id="61" name="Text 51"/>
           <p:cNvSpPr txBox="1"/>
           <p:nvPr/>
         </p:nvSpPr>
@@ -6581,7 +6583,7 @@
       </p:sp>
       <p:sp>
         <p:nvSpPr>
-          <p:cNvPr id="62" name="Shape 53"/>
+          <p:cNvPr id="62" name="Shape 52"/>
           <p:cNvSpPr/>
           <p:nvPr/>
         </p:nvSpPr>
@@ -6615,7 +6617,7 @@
       </p:sp>
       <p:sp>
         <p:nvSpPr>
-          <p:cNvPr id="63" name="Text 54"/>
+          <p:cNvPr id="63" name="Text 53"/>
           <p:cNvSpPr txBox="1"/>
           <p:nvPr/>
         </p:nvSpPr>
@@ -6654,7 +6656,7 @@
       </p:sp>
       <p:sp>
         <p:nvSpPr>
-          <p:cNvPr id="64" name="Shape 55"/>
+          <p:cNvPr id="64" name="Shape 54"/>
           <p:cNvSpPr/>
           <p:nvPr/>
         </p:nvSpPr>
@@ -6681,7 +6683,7 @@
       </p:sp>
       <p:sp>
         <p:nvSpPr>
-          <p:cNvPr id="65" name="Text 56"/>
+          <p:cNvPr id="65" name="Text 55"/>
           <p:cNvSpPr txBox="1"/>
           <p:nvPr/>
         </p:nvSpPr>
@@ -6720,7 +6722,7 @@
       </p:sp>
       <p:sp>
         <p:nvSpPr>
-          <p:cNvPr id="66" name="Text 57"/>
+          <p:cNvPr id="66" name="Text 56"/>
           <p:cNvSpPr txBox="1"/>
           <p:nvPr/>
         </p:nvSpPr>
@@ -6762,7 +6764,7 @@
       </p:sp>
       <p:sp>
         <p:nvSpPr>
-          <p:cNvPr id="67" name="Text 58"/>
+          <p:cNvPr id="67" name="Text 57"/>
           <p:cNvSpPr txBox="1"/>
           <p:nvPr/>
         </p:nvSpPr>
@@ -6804,7 +6806,7 @@
       </p:sp>
       <p:sp>
         <p:nvSpPr>
-          <p:cNvPr id="68" name="Shape 59"/>
+          <p:cNvPr id="68" name="Shape 58"/>
           <p:cNvSpPr/>
           <p:nvPr/>
         </p:nvSpPr>
@@ -6827,7 +6829,7 @@
       </p:sp>
       <p:sp>
         <p:nvSpPr>
-          <p:cNvPr id="69" name="Text 60"/>
+          <p:cNvPr id="69" name="Text 59"/>
           <p:cNvSpPr txBox="1"/>
           <p:nvPr/>
         </p:nvSpPr>
@@ -6866,7 +6868,7 @@
       </p:sp>
       <p:sp>
         <p:nvSpPr>
-          <p:cNvPr id="70" name="Text 61"/>
+          <p:cNvPr id="70" name="Text 60"/>
           <p:cNvSpPr txBox="1"/>
           <p:nvPr/>
         </p:nvSpPr>
@@ -6905,7 +6907,7 @@
       </p:sp>
       <p:sp>
         <p:nvSpPr>
-          <p:cNvPr id="71" name="Shape 62"/>
+          <p:cNvPr id="71" name="Shape 61"/>
           <p:cNvSpPr/>
           <p:nvPr/>
         </p:nvSpPr>
@@ -6939,7 +6941,7 @@
       </p:sp>
       <p:sp>
         <p:nvSpPr>
-          <p:cNvPr id="72" name="Text 63"/>
+          <p:cNvPr id="72" name="Text 62"/>
           <p:cNvSpPr txBox="1"/>
           <p:nvPr/>
         </p:nvSpPr>
@@ -6978,7 +6980,7 @@
       </p:sp>
       <p:sp>
         <p:nvSpPr>
-          <p:cNvPr id="73" name="Text 64"/>
+          <p:cNvPr id="73" name="Text 63"/>
           <p:cNvSpPr txBox="1"/>
           <p:nvPr/>
         </p:nvSpPr>
@@ -7020,7 +7022,7 @@
       </p:sp>
       <p:sp>
         <p:nvSpPr>
-          <p:cNvPr id="74" name="Text 65"/>
+          <p:cNvPr id="74" name="Text 64"/>
           <p:cNvSpPr txBox="1"/>
           <p:nvPr/>
         </p:nvSpPr>
@@ -7062,7 +7064,7 @@
       </p:sp>
       <p:sp>
         <p:nvSpPr>
-          <p:cNvPr id="75" name="Shape 66"/>
+          <p:cNvPr id="75" name="Shape 65"/>
           <p:cNvSpPr/>
           <p:nvPr/>
         </p:nvSpPr>
@@ -7085,7 +7087,7 @@
       </p:sp>
       <p:sp>
         <p:nvSpPr>
-          <p:cNvPr id="76" name="Text 67"/>
+          <p:cNvPr id="76" name="Text 66"/>
           <p:cNvSpPr txBox="1"/>
           <p:nvPr/>
         </p:nvSpPr>
@@ -7124,7 +7126,7 @@
       </p:sp>
       <p:sp>
         <p:nvSpPr>
-          <p:cNvPr id="77" name="Text 68"/>
+          <p:cNvPr id="77" name="Text 67"/>
           <p:cNvSpPr txBox="1"/>
           <p:nvPr/>
         </p:nvSpPr>
@@ -7163,7 +7165,7 @@
       </p:sp>
       <p:sp>
         <p:nvSpPr>
-          <p:cNvPr id="78" name="Shape 69"/>
+          <p:cNvPr id="78" name="Shape 68"/>
           <p:cNvSpPr/>
           <p:nvPr/>
         </p:nvSpPr>
@@ -7183,7 +7185,7 @@
       </p:sp>
       <p:sp>
         <p:nvSpPr>
-          <p:cNvPr id="79" name="Text 70"/>
+          <p:cNvPr id="79" name="Text 69"/>
           <p:cNvSpPr txBox="1"/>
           <p:nvPr/>
         </p:nvSpPr>
@@ -7222,7 +7224,7 @@
       </p:sp>
       <p:sp>
         <p:nvSpPr>
-          <p:cNvPr id="80" name="Shape 71"/>
+          <p:cNvPr id="80" name="Shape 70"/>
           <p:cNvSpPr/>
           <p:nvPr/>
         </p:nvSpPr>
@@ -7249,7 +7251,7 @@
       </p:sp>
       <p:sp>
         <p:nvSpPr>
-          <p:cNvPr id="81" name="Shape 72"/>
+          <p:cNvPr id="81" name="Shape 71"/>
           <p:cNvSpPr/>
           <p:nvPr/>
         </p:nvSpPr>
@@ -7269,7 +7271,7 @@
       </p:sp>
       <p:sp>
         <p:nvSpPr>
-          <p:cNvPr id="82" name="Text 73"/>
+          <p:cNvPr id="82" name="Text 72"/>
           <p:cNvSpPr txBox="1"/>
           <p:nvPr/>
         </p:nvSpPr>
@@ -7308,7 +7310,7 @@
       </p:sp>
       <p:sp>
         <p:nvSpPr>
-          <p:cNvPr id="83" name="Text 74"/>
+          <p:cNvPr id="83" name="Text 73"/>
           <p:cNvSpPr txBox="1"/>
           <p:nvPr/>
         </p:nvSpPr>
@@ -7347,7 +7349,7 @@
       </p:sp>
       <p:sp>
         <p:nvSpPr>
-          <p:cNvPr id="84" name="Text 75"/>
+          <p:cNvPr id="84" name="Text 74"/>
           <p:cNvSpPr txBox="1"/>
           <p:nvPr/>
         </p:nvSpPr>

</xml_diff>